<commit_message>
Added slides with images and enhanced documentation with them.
</commit_message>
<xml_diff>
--- a/docs/Simulator.pptx
+++ b/docs/Simulator.pptx
@@ -200,7 +200,7 @@
           <a:p>
             <a:fld id="{5C4746B9-973E-42EE-833B-2CCE415A7F55}" type="datetimeFigureOut">
               <a:rPr lang="en-US" smtClean="0"/>
-              <a:t>1/15/2026</a:t>
+              <a:t>1/17/2026</a:t>
             </a:fld>
             <a:endParaRPr lang="en-US"/>
           </a:p>
@@ -914,7 +914,7 @@
           <a:p>
             <a:fld id="{52CBEE99-EB13-440C-B182-3BC3988FEC29}" type="datetimeFigureOut">
               <a:rPr lang="en-US" smtClean="0"/>
-              <a:t>1/15/2026</a:t>
+              <a:t>1/17/2026</a:t>
             </a:fld>
             <a:endParaRPr lang="en-US"/>
           </a:p>
@@ -1112,7 +1112,7 @@
           <a:p>
             <a:fld id="{52CBEE99-EB13-440C-B182-3BC3988FEC29}" type="datetimeFigureOut">
               <a:rPr lang="en-US" smtClean="0"/>
-              <a:t>1/15/2026</a:t>
+              <a:t>1/17/2026</a:t>
             </a:fld>
             <a:endParaRPr lang="en-US"/>
           </a:p>
@@ -1320,7 +1320,7 @@
           <a:p>
             <a:fld id="{52CBEE99-EB13-440C-B182-3BC3988FEC29}" type="datetimeFigureOut">
               <a:rPr lang="en-US" smtClean="0"/>
-              <a:t>1/15/2026</a:t>
+              <a:t>1/17/2026</a:t>
             </a:fld>
             <a:endParaRPr lang="en-US"/>
           </a:p>
@@ -1518,7 +1518,7 @@
           <a:p>
             <a:fld id="{52CBEE99-EB13-440C-B182-3BC3988FEC29}" type="datetimeFigureOut">
               <a:rPr lang="en-US" smtClean="0"/>
-              <a:t>1/15/2026</a:t>
+              <a:t>1/17/2026</a:t>
             </a:fld>
             <a:endParaRPr lang="en-US"/>
           </a:p>
@@ -1793,7 +1793,7 @@
           <a:p>
             <a:fld id="{52CBEE99-EB13-440C-B182-3BC3988FEC29}" type="datetimeFigureOut">
               <a:rPr lang="en-US" smtClean="0"/>
-              <a:t>1/15/2026</a:t>
+              <a:t>1/17/2026</a:t>
             </a:fld>
             <a:endParaRPr lang="en-US"/>
           </a:p>
@@ -2058,7 +2058,7 @@
           <a:p>
             <a:fld id="{52CBEE99-EB13-440C-B182-3BC3988FEC29}" type="datetimeFigureOut">
               <a:rPr lang="en-US" smtClean="0"/>
-              <a:t>1/15/2026</a:t>
+              <a:t>1/17/2026</a:t>
             </a:fld>
             <a:endParaRPr lang="en-US"/>
           </a:p>
@@ -2470,7 +2470,7 @@
           <a:p>
             <a:fld id="{52CBEE99-EB13-440C-B182-3BC3988FEC29}" type="datetimeFigureOut">
               <a:rPr lang="en-US" smtClean="0"/>
-              <a:t>1/15/2026</a:t>
+              <a:t>1/17/2026</a:t>
             </a:fld>
             <a:endParaRPr lang="en-US"/>
           </a:p>
@@ -2611,7 +2611,7 @@
           <a:p>
             <a:fld id="{52CBEE99-EB13-440C-B182-3BC3988FEC29}" type="datetimeFigureOut">
               <a:rPr lang="en-US" smtClean="0"/>
-              <a:t>1/15/2026</a:t>
+              <a:t>1/17/2026</a:t>
             </a:fld>
             <a:endParaRPr lang="en-US"/>
           </a:p>
@@ -2724,7 +2724,7 @@
           <a:p>
             <a:fld id="{52CBEE99-EB13-440C-B182-3BC3988FEC29}" type="datetimeFigureOut">
               <a:rPr lang="en-US" smtClean="0"/>
-              <a:t>1/15/2026</a:t>
+              <a:t>1/17/2026</a:t>
             </a:fld>
             <a:endParaRPr lang="en-US"/>
           </a:p>
@@ -3035,7 +3035,7 @@
           <a:p>
             <a:fld id="{52CBEE99-EB13-440C-B182-3BC3988FEC29}" type="datetimeFigureOut">
               <a:rPr lang="en-US" smtClean="0"/>
-              <a:t>1/15/2026</a:t>
+              <a:t>1/17/2026</a:t>
             </a:fld>
             <a:endParaRPr lang="en-US"/>
           </a:p>
@@ -3323,7 +3323,7 @@
           <a:p>
             <a:fld id="{52CBEE99-EB13-440C-B182-3BC3988FEC29}" type="datetimeFigureOut">
               <a:rPr lang="en-US" smtClean="0"/>
-              <a:t>1/15/2026</a:t>
+              <a:t>1/17/2026</a:t>
             </a:fld>
             <a:endParaRPr lang="en-US"/>
           </a:p>
@@ -3564,7 +3564,7 @@
           <a:p>
             <a:fld id="{52CBEE99-EB13-440C-B182-3BC3988FEC29}" type="datetimeFigureOut">
               <a:rPr lang="en-US" smtClean="0"/>
-              <a:t>1/15/2026</a:t>
+              <a:t>1/17/2026</a:t>
             </a:fld>
             <a:endParaRPr lang="en-US"/>
           </a:p>
@@ -4114,8 +4114,8 @@
           </a:p>
         </p:txBody>
       </p:sp>
-      <mc:AlternateContent xmlns:mc="http://schemas.openxmlformats.org/markup-compatibility/2006">
-        <mc:Choice xmlns:a14="http://schemas.microsoft.com/office/drawing/2010/main" Requires="a14">
+      <mc:AlternateContent xmlns:mc="http://schemas.openxmlformats.org/markup-compatibility/2006" xmlns:a14="http://schemas.microsoft.com/office/drawing/2010/main">
+        <mc:Choice Requires="a14">
           <p:sp>
             <p:nvSpPr>
               <p:cNvPr id="44" name="Rectangle 43">
@@ -4215,7 +4215,7 @@
             </p:txBody>
           </p:sp>
         </mc:Choice>
-        <mc:Fallback>
+        <mc:Fallback xmlns="">
           <p:sp>
             <p:nvSpPr>
               <p:cNvPr id="44" name="Rectangle 43">
@@ -4260,8 +4260,8 @@
           </p:sp>
         </mc:Fallback>
       </mc:AlternateContent>
-      <mc:AlternateContent xmlns:mc="http://schemas.openxmlformats.org/markup-compatibility/2006">
-        <mc:Choice xmlns:a14="http://schemas.microsoft.com/office/drawing/2010/main" Requires="a14">
+      <mc:AlternateContent xmlns:mc="http://schemas.openxmlformats.org/markup-compatibility/2006" xmlns:a14="http://schemas.microsoft.com/office/drawing/2010/main">
+        <mc:Choice Requires="a14">
           <p:sp>
             <p:nvSpPr>
               <p:cNvPr id="46" name="Rectangle 45">
@@ -4361,7 +4361,7 @@
             </p:txBody>
           </p:sp>
         </mc:Choice>
-        <mc:Fallback>
+        <mc:Fallback xmlns="">
           <p:sp>
             <p:nvSpPr>
               <p:cNvPr id="46" name="Rectangle 45">
@@ -4406,8 +4406,8 @@
           </p:sp>
         </mc:Fallback>
       </mc:AlternateContent>
-      <mc:AlternateContent xmlns:mc="http://schemas.openxmlformats.org/markup-compatibility/2006">
-        <mc:Choice xmlns:a14="http://schemas.microsoft.com/office/drawing/2010/main" Requires="a14">
+      <mc:AlternateContent xmlns:mc="http://schemas.openxmlformats.org/markup-compatibility/2006" xmlns:a14="http://schemas.microsoft.com/office/drawing/2010/main">
+        <mc:Choice Requires="a14">
           <p:sp>
             <p:nvSpPr>
               <p:cNvPr id="54" name="Speech Bubble: Rectangle with Corners Rounded 53">
@@ -4636,7 +4636,7 @@
             </p:txBody>
           </p:sp>
         </mc:Choice>
-        <mc:Fallback>
+        <mc:Fallback xmlns="">
           <p:sp>
             <p:nvSpPr>
               <p:cNvPr id="54" name="Speech Bubble: Rectangle with Corners Rounded 53">
@@ -4690,8 +4690,8 @@
           </p:sp>
         </mc:Fallback>
       </mc:AlternateContent>
-      <mc:AlternateContent xmlns:mc="http://schemas.openxmlformats.org/markup-compatibility/2006">
-        <mc:Choice xmlns:a14="http://schemas.microsoft.com/office/drawing/2010/main" Requires="a14">
+      <mc:AlternateContent xmlns:mc="http://schemas.openxmlformats.org/markup-compatibility/2006" xmlns:a14="http://schemas.microsoft.com/office/drawing/2010/main">
+        <mc:Choice Requires="a14">
           <p:sp>
             <p:nvSpPr>
               <p:cNvPr id="59" name="Speech Bubble: Rectangle with Corners Rounded 58">
@@ -4920,7 +4920,7 @@
             </p:txBody>
           </p:sp>
         </mc:Choice>
-        <mc:Fallback>
+        <mc:Fallback xmlns="">
           <p:sp>
             <p:nvSpPr>
               <p:cNvPr id="59" name="Speech Bubble: Rectangle with Corners Rounded 58">
@@ -5260,8 +5260,8 @@
           </a:p>
         </p:txBody>
       </p:sp>
-      <mc:AlternateContent xmlns:mc="http://schemas.openxmlformats.org/markup-compatibility/2006">
-        <mc:Choice xmlns:a14="http://schemas.microsoft.com/office/drawing/2010/main" Requires="a14">
+      <mc:AlternateContent xmlns:mc="http://schemas.openxmlformats.org/markup-compatibility/2006" xmlns:a14="http://schemas.microsoft.com/office/drawing/2010/main">
+        <mc:Choice Requires="a14">
           <p:sp>
             <p:nvSpPr>
               <p:cNvPr id="462" name="TextBox 461">
@@ -5342,7 +5342,7 @@
             </p:txBody>
           </p:sp>
         </mc:Choice>
-        <mc:Fallback>
+        <mc:Fallback xmlns="">
           <p:sp>
             <p:nvSpPr>
               <p:cNvPr id="462" name="TextBox 461">
@@ -5387,8 +5387,8 @@
           </p:sp>
         </mc:Fallback>
       </mc:AlternateContent>
-      <mc:AlternateContent xmlns:mc="http://schemas.openxmlformats.org/markup-compatibility/2006">
-        <mc:Choice xmlns:a14="http://schemas.microsoft.com/office/drawing/2010/main" Requires="a14">
+      <mc:AlternateContent xmlns:mc="http://schemas.openxmlformats.org/markup-compatibility/2006" xmlns:a14="http://schemas.microsoft.com/office/drawing/2010/main">
+        <mc:Choice Requires="a14">
           <p:sp>
             <p:nvSpPr>
               <p:cNvPr id="469" name="Speech Bubble: Rectangle with Corners Rounded 468">
@@ -5774,7 +5774,7 @@
             </p:txBody>
           </p:sp>
         </mc:Choice>
-        <mc:Fallback>
+        <mc:Fallback xmlns="">
           <p:sp>
             <p:nvSpPr>
               <p:cNvPr id="469" name="Speech Bubble: Rectangle with Corners Rounded 468">
@@ -5828,8 +5828,8 @@
           </p:sp>
         </mc:Fallback>
       </mc:AlternateContent>
-      <mc:AlternateContent xmlns:mc="http://schemas.openxmlformats.org/markup-compatibility/2006">
-        <mc:Choice xmlns:a14="http://schemas.microsoft.com/office/drawing/2010/main" Requires="a14">
+      <mc:AlternateContent xmlns:mc="http://schemas.openxmlformats.org/markup-compatibility/2006" xmlns:a14="http://schemas.microsoft.com/office/drawing/2010/main">
+        <mc:Choice Requires="a14">
           <p:sp>
             <p:nvSpPr>
               <p:cNvPr id="70" name="TextBox 69">
@@ -5941,7 +5941,7 @@
             </p:txBody>
           </p:sp>
         </mc:Choice>
-        <mc:Fallback>
+        <mc:Fallback xmlns="">
           <p:sp>
             <p:nvSpPr>
               <p:cNvPr id="70" name="TextBox 69">
@@ -5986,8 +5986,8 @@
           </p:sp>
         </mc:Fallback>
       </mc:AlternateContent>
-      <mc:AlternateContent xmlns:mc="http://schemas.openxmlformats.org/markup-compatibility/2006">
-        <mc:Choice xmlns:a14="http://schemas.microsoft.com/office/drawing/2010/main" Requires="a14">
+      <mc:AlternateContent xmlns:mc="http://schemas.openxmlformats.org/markup-compatibility/2006" xmlns:a14="http://schemas.microsoft.com/office/drawing/2010/main">
+        <mc:Choice Requires="a14">
           <p:sp>
             <p:nvSpPr>
               <p:cNvPr id="71" name="TextBox 70">
@@ -6099,7 +6099,7 @@
             </p:txBody>
           </p:sp>
         </mc:Choice>
-        <mc:Fallback>
+        <mc:Fallback xmlns="">
           <p:sp>
             <p:nvSpPr>
               <p:cNvPr id="71" name="TextBox 70">
@@ -6795,8 +6795,8 @@
           </p:style>
         </p:cxnSp>
       </p:grpSp>
-      <mc:AlternateContent xmlns:mc="http://schemas.openxmlformats.org/markup-compatibility/2006">
-        <mc:Choice xmlns:a14="http://schemas.microsoft.com/office/drawing/2010/main" Requires="a14">
+      <mc:AlternateContent xmlns:mc="http://schemas.openxmlformats.org/markup-compatibility/2006" xmlns:a14="http://schemas.microsoft.com/office/drawing/2010/main">
+        <mc:Choice Requires="a14">
           <p:sp>
             <p:nvSpPr>
               <p:cNvPr id="460" name="TextBox 459">
@@ -6877,7 +6877,7 @@
             </p:txBody>
           </p:sp>
         </mc:Choice>
-        <mc:Fallback>
+        <mc:Fallback xmlns="">
           <p:sp>
             <p:nvSpPr>
               <p:cNvPr id="460" name="TextBox 459">
@@ -6922,8 +6922,8 @@
           </p:sp>
         </mc:Fallback>
       </mc:AlternateContent>
-      <mc:AlternateContent xmlns:mc="http://schemas.openxmlformats.org/markup-compatibility/2006">
-        <mc:Choice xmlns:a14="http://schemas.microsoft.com/office/drawing/2010/main" Requires="a14">
+      <mc:AlternateContent xmlns:mc="http://schemas.openxmlformats.org/markup-compatibility/2006" xmlns:a14="http://schemas.microsoft.com/office/drawing/2010/main">
+        <mc:Choice Requires="a14">
           <p:sp>
             <p:nvSpPr>
               <p:cNvPr id="461" name="TextBox 460">
@@ -7004,7 +7004,7 @@
             </p:txBody>
           </p:sp>
         </mc:Choice>
-        <mc:Fallback>
+        <mc:Fallback xmlns="">
           <p:sp>
             <p:nvSpPr>
               <p:cNvPr id="461" name="TextBox 460">
@@ -7049,8 +7049,8 @@
           </p:sp>
         </mc:Fallback>
       </mc:AlternateContent>
-      <mc:AlternateContent xmlns:mc="http://schemas.openxmlformats.org/markup-compatibility/2006">
-        <mc:Choice xmlns:a14="http://schemas.microsoft.com/office/drawing/2010/main" Requires="a14">
+      <mc:AlternateContent xmlns:mc="http://schemas.openxmlformats.org/markup-compatibility/2006" xmlns:a14="http://schemas.microsoft.com/office/drawing/2010/main">
+        <mc:Choice Requires="a14">
           <p:sp>
             <p:nvSpPr>
               <p:cNvPr id="83" name="TextBox 82">
@@ -7260,6 +7260,7 @@
                 </a:r>
               </a:p>
               <a:p>
+                <a:pPr/>
                 <a14:m>
                   <m:oMathPara xmlns:m="http://schemas.openxmlformats.org/officeDocument/2006/math">
                     <m:oMathParaPr>
@@ -7663,7 +7664,7 @@
             </p:txBody>
           </p:sp>
         </mc:Choice>
-        <mc:Fallback>
+        <mc:Fallback xmlns="">
           <p:sp>
             <p:nvSpPr>
               <p:cNvPr id="83" name="TextBox 82">
@@ -7838,8 +7839,8 @@
           </a:p>
         </p:txBody>
       </p:sp>
-      <mc:AlternateContent xmlns:mc="http://schemas.openxmlformats.org/markup-compatibility/2006">
-        <mc:Choice xmlns:a14="http://schemas.microsoft.com/office/drawing/2010/main" Requires="a14">
+      <mc:AlternateContent xmlns:mc="http://schemas.openxmlformats.org/markup-compatibility/2006" xmlns:a14="http://schemas.microsoft.com/office/drawing/2010/main">
+        <mc:Choice Requires="a14">
           <p:sp>
             <p:nvSpPr>
               <p:cNvPr id="44" name="Rectangle 43">
@@ -7939,7 +7940,7 @@
             </p:txBody>
           </p:sp>
         </mc:Choice>
-        <mc:Fallback>
+        <mc:Fallback xmlns="">
           <p:sp>
             <p:nvSpPr>
               <p:cNvPr id="44" name="Rectangle 43">
@@ -7984,8 +7985,8 @@
           </p:sp>
         </mc:Fallback>
       </mc:AlternateContent>
-      <mc:AlternateContent xmlns:mc="http://schemas.openxmlformats.org/markup-compatibility/2006">
-        <mc:Choice xmlns:a14="http://schemas.microsoft.com/office/drawing/2010/main" Requires="a14">
+      <mc:AlternateContent xmlns:mc="http://schemas.openxmlformats.org/markup-compatibility/2006" xmlns:a14="http://schemas.microsoft.com/office/drawing/2010/main">
+        <mc:Choice Requires="a14">
           <p:sp>
             <p:nvSpPr>
               <p:cNvPr id="46" name="Rectangle 45">
@@ -8085,7 +8086,7 @@
             </p:txBody>
           </p:sp>
         </mc:Choice>
-        <mc:Fallback>
+        <mc:Fallback xmlns="">
           <p:sp>
             <p:nvSpPr>
               <p:cNvPr id="46" name="Rectangle 45">
@@ -8130,8 +8131,8 @@
           </p:sp>
         </mc:Fallback>
       </mc:AlternateContent>
-      <mc:AlternateContent xmlns:mc="http://schemas.openxmlformats.org/markup-compatibility/2006">
-        <mc:Choice xmlns:a14="http://schemas.microsoft.com/office/drawing/2010/main" Requires="a14">
+      <mc:AlternateContent xmlns:mc="http://schemas.openxmlformats.org/markup-compatibility/2006" xmlns:a14="http://schemas.microsoft.com/office/drawing/2010/main">
+        <mc:Choice Requires="a14">
           <p:sp>
             <p:nvSpPr>
               <p:cNvPr id="54" name="Speech Bubble: Rectangle with Corners Rounded 53">
@@ -8360,7 +8361,7 @@
             </p:txBody>
           </p:sp>
         </mc:Choice>
-        <mc:Fallback>
+        <mc:Fallback xmlns="">
           <p:sp>
             <p:nvSpPr>
               <p:cNvPr id="54" name="Speech Bubble: Rectangle with Corners Rounded 53">
@@ -8414,8 +8415,8 @@
           </p:sp>
         </mc:Fallback>
       </mc:AlternateContent>
-      <mc:AlternateContent xmlns:mc="http://schemas.openxmlformats.org/markup-compatibility/2006">
-        <mc:Choice xmlns:a14="http://schemas.microsoft.com/office/drawing/2010/main" Requires="a14">
+      <mc:AlternateContent xmlns:mc="http://schemas.openxmlformats.org/markup-compatibility/2006" xmlns:a14="http://schemas.microsoft.com/office/drawing/2010/main">
+        <mc:Choice Requires="a14">
           <p:sp>
             <p:nvSpPr>
               <p:cNvPr id="59" name="Speech Bubble: Rectangle with Corners Rounded 58">
@@ -8644,7 +8645,7 @@
             </p:txBody>
           </p:sp>
         </mc:Choice>
-        <mc:Fallback>
+        <mc:Fallback xmlns="">
           <p:sp>
             <p:nvSpPr>
               <p:cNvPr id="59" name="Speech Bubble: Rectangle with Corners Rounded 58">
@@ -8911,8 +8912,8 @@
             </p:style>
           </p:cxnSp>
         </p:grpSp>
-        <mc:AlternateContent xmlns:mc="http://schemas.openxmlformats.org/markup-compatibility/2006">
-          <mc:Choice xmlns:a14="http://schemas.microsoft.com/office/drawing/2010/main" Requires="a14">
+        <mc:AlternateContent xmlns:mc="http://schemas.openxmlformats.org/markup-compatibility/2006" xmlns:a14="http://schemas.microsoft.com/office/drawing/2010/main">
+          <mc:Choice Requires="a14">
             <p:sp>
               <p:nvSpPr>
                 <p:cNvPr id="462" name="TextBox 461">
@@ -8993,7 +8994,7 @@
               </p:txBody>
             </p:sp>
           </mc:Choice>
-          <mc:Fallback>
+          <mc:Fallback xmlns="">
             <p:sp>
               <p:nvSpPr>
                 <p:cNvPr id="462" name="TextBox 461">
@@ -9039,8 +9040,8 @@
           </mc:Fallback>
         </mc:AlternateContent>
       </p:grpSp>
-      <mc:AlternateContent xmlns:mc="http://schemas.openxmlformats.org/markup-compatibility/2006">
-        <mc:Choice xmlns:a14="http://schemas.microsoft.com/office/drawing/2010/main" Requires="a14">
+      <mc:AlternateContent xmlns:mc="http://schemas.openxmlformats.org/markup-compatibility/2006" xmlns:a14="http://schemas.microsoft.com/office/drawing/2010/main">
+        <mc:Choice Requires="a14">
           <p:sp>
             <p:nvSpPr>
               <p:cNvPr id="71" name="TextBox 70">
@@ -9152,7 +9153,7 @@
             </p:txBody>
           </p:sp>
         </mc:Choice>
-        <mc:Fallback>
+        <mc:Fallback xmlns="">
           <p:sp>
             <p:nvSpPr>
               <p:cNvPr id="71" name="TextBox 70">
@@ -9197,8 +9198,8 @@
           </p:sp>
         </mc:Fallback>
       </mc:AlternateContent>
-      <mc:AlternateContent xmlns:mc="http://schemas.openxmlformats.org/markup-compatibility/2006">
-        <mc:Choice xmlns:a14="http://schemas.microsoft.com/office/drawing/2010/main" Requires="a14">
+      <mc:AlternateContent xmlns:mc="http://schemas.openxmlformats.org/markup-compatibility/2006" xmlns:a14="http://schemas.microsoft.com/office/drawing/2010/main">
+        <mc:Choice Requires="a14">
           <p:sp>
             <p:nvSpPr>
               <p:cNvPr id="13" name="Isosceles Triangle 12">
@@ -9303,7 +9304,7 @@
             </p:txBody>
           </p:sp>
         </mc:Choice>
-        <mc:Fallback>
+        <mc:Fallback xmlns="">
           <p:sp>
             <p:nvSpPr>
               <p:cNvPr id="13" name="Isosceles Triangle 12">
@@ -9726,8 +9727,8 @@
             </p:style>
           </p:cxnSp>
         </p:grpSp>
-        <mc:AlternateContent xmlns:mc="http://schemas.openxmlformats.org/markup-compatibility/2006">
-          <mc:Choice xmlns:a14="http://schemas.microsoft.com/office/drawing/2010/main" Requires="a14">
+        <mc:AlternateContent xmlns:mc="http://schemas.openxmlformats.org/markup-compatibility/2006" xmlns:a14="http://schemas.microsoft.com/office/drawing/2010/main">
+          <mc:Choice Requires="a14">
             <p:sp>
               <p:nvSpPr>
                 <p:cNvPr id="8" name="TextBox 7">
@@ -9808,7 +9809,7 @@
               </p:txBody>
             </p:sp>
           </mc:Choice>
-          <mc:Fallback>
+          <mc:Fallback xmlns="">
             <p:sp>
               <p:nvSpPr>
                 <p:cNvPr id="8" name="TextBox 7">
@@ -9854,8 +9855,8 @@
           </mc:Fallback>
         </mc:AlternateContent>
       </p:grpSp>
-      <mc:AlternateContent xmlns:mc="http://schemas.openxmlformats.org/markup-compatibility/2006">
-        <mc:Choice xmlns:a14="http://schemas.microsoft.com/office/drawing/2010/main" Requires="a14">
+      <mc:AlternateContent xmlns:mc="http://schemas.openxmlformats.org/markup-compatibility/2006" xmlns:a14="http://schemas.microsoft.com/office/drawing/2010/main">
+        <mc:Choice Requires="a14">
           <p:sp>
             <p:nvSpPr>
               <p:cNvPr id="42" name="Speech Bubble: Rectangle with Corners Rounded 41">
@@ -9974,7 +9975,7 @@
             </p:txBody>
           </p:sp>
         </mc:Choice>
-        <mc:Fallback>
+        <mc:Fallback xmlns="">
           <p:sp>
             <p:nvSpPr>
               <p:cNvPr id="42" name="Speech Bubble: Rectangle with Corners Rounded 41">
@@ -10232,6 +10233,124 @@
       </p:grpSpPr>
       <p:sp>
         <p:nvSpPr>
+          <p:cNvPr id="80" name="Rectangle: Rounded Corners 79">
+            <a:extLst>
+              <a:ext uri="{FF2B5EF4-FFF2-40B4-BE49-F238E27FC236}">
+                <a16:creationId xmlns:a16="http://schemas.microsoft.com/office/drawing/2014/main" id="{211506DD-2523-B054-099E-4C94F281882F}"/>
+              </a:ext>
+            </a:extLst>
+          </p:cNvPr>
+          <p:cNvSpPr/>
+          <p:nvPr/>
+        </p:nvSpPr>
+        <p:spPr>
+          <a:xfrm>
+            <a:off x="6468177" y="188360"/>
+            <a:ext cx="5646023" cy="1273660"/>
+          </a:xfrm>
+          <a:prstGeom prst="roundRect">
+            <a:avLst>
+              <a:gd name="adj" fmla="val 22652"/>
+            </a:avLst>
+          </a:prstGeom>
+          <a:solidFill>
+            <a:schemeClr val="accent6">
+              <a:lumMod val="20000"/>
+              <a:lumOff val="80000"/>
+            </a:schemeClr>
+          </a:solidFill>
+          <a:ln>
+            <a:solidFill>
+              <a:schemeClr val="tx1"/>
+            </a:solidFill>
+          </a:ln>
+        </p:spPr>
+        <p:style>
+          <a:lnRef idx="2">
+            <a:schemeClr val="accent1">
+              <a:shade val="15000"/>
+            </a:schemeClr>
+          </a:lnRef>
+          <a:fillRef idx="1">
+            <a:schemeClr val="accent1"/>
+          </a:fillRef>
+          <a:effectRef idx="0">
+            <a:schemeClr val="accent1"/>
+          </a:effectRef>
+          <a:fontRef idx="minor">
+            <a:schemeClr val="lt1"/>
+          </a:fontRef>
+        </p:style>
+        <p:txBody>
+          <a:bodyPr rtlCol="0" anchor="ctr"/>
+          <a:lstStyle/>
+          <a:p>
+            <a:pPr algn="ctr"/>
+            <a:endParaRPr lang="en-US"/>
+          </a:p>
+        </p:txBody>
+      </p:sp>
+      <p:sp>
+        <p:nvSpPr>
+          <p:cNvPr id="79" name="Rectangle: Rounded Corners 78">
+            <a:extLst>
+              <a:ext uri="{FF2B5EF4-FFF2-40B4-BE49-F238E27FC236}">
+                <a16:creationId xmlns:a16="http://schemas.microsoft.com/office/drawing/2014/main" id="{DD39D050-838D-499D-7CDF-6FA4FCF56291}"/>
+              </a:ext>
+            </a:extLst>
+          </p:cNvPr>
+          <p:cNvSpPr/>
+          <p:nvPr/>
+        </p:nvSpPr>
+        <p:spPr>
+          <a:xfrm>
+            <a:off x="452387" y="1617044"/>
+            <a:ext cx="7536581" cy="5052597"/>
+          </a:xfrm>
+          <a:prstGeom prst="roundRect">
+            <a:avLst>
+              <a:gd name="adj" fmla="val 5427"/>
+            </a:avLst>
+          </a:prstGeom>
+          <a:solidFill>
+            <a:schemeClr val="tx2">
+              <a:lumMod val="10000"/>
+              <a:lumOff val="90000"/>
+            </a:schemeClr>
+          </a:solidFill>
+          <a:ln>
+            <a:solidFill>
+              <a:schemeClr val="tx1"/>
+            </a:solidFill>
+          </a:ln>
+        </p:spPr>
+        <p:style>
+          <a:lnRef idx="2">
+            <a:schemeClr val="accent1">
+              <a:shade val="15000"/>
+            </a:schemeClr>
+          </a:lnRef>
+          <a:fillRef idx="1">
+            <a:schemeClr val="accent1"/>
+          </a:fillRef>
+          <a:effectRef idx="0">
+            <a:schemeClr val="accent1"/>
+          </a:effectRef>
+          <a:fontRef idx="minor">
+            <a:schemeClr val="lt1"/>
+          </a:fontRef>
+        </p:style>
+        <p:txBody>
+          <a:bodyPr rtlCol="0" anchor="ctr"/>
+          <a:lstStyle/>
+          <a:p>
+            <a:pPr algn="ctr"/>
+            <a:endParaRPr lang="en-US" dirty="0"/>
+          </a:p>
+        </p:txBody>
+      </p:sp>
+      <p:sp>
+        <p:nvSpPr>
           <p:cNvPr id="4" name="Title 1">
             <a:extLst>
               <a:ext uri="{FF2B5EF4-FFF2-40B4-BE49-F238E27FC236}">
@@ -10249,7 +10368,7 @@
         <p:spPr>
           <a:xfrm>
             <a:off x="0" y="1"/>
-            <a:ext cx="12192000" cy="668458"/>
+            <a:ext cx="4504210" cy="491884"/>
           </a:xfrm>
         </p:spPr>
         <p:txBody>
@@ -10259,7 +10378,7 @@
           <a:lstStyle/>
           <a:p>
             <a:r>
-              <a:rPr lang="en-US" dirty="0"/>
+              <a:rPr lang="en-US" sz="3200" dirty="0"/>
               <a:t>UML Class Diagram</a:t>
             </a:r>
           </a:p>
@@ -10279,8 +10398,8 @@
         </p:nvSpPr>
         <p:spPr>
           <a:xfrm>
-            <a:off x="1549400" y="1465143"/>
-            <a:ext cx="2882900" cy="668457"/>
+            <a:off x="2684039" y="1747416"/>
+            <a:ext cx="3004492" cy="383276"/>
           </a:xfrm>
           <a:prstGeom prst="rect">
             <a:avLst/>
@@ -10314,14 +10433,14 @@
           <a:p>
             <a:pPr algn="ctr"/>
             <a:r>
-              <a:rPr lang="en-US" b="1" dirty="0" err="1">
+              <a:rPr lang="en-US" sz="1050" b="1" dirty="0" err="1">
                 <a:solidFill>
                   <a:schemeClr val="tx1"/>
                 </a:solidFill>
               </a:rPr>
               <a:t>CommNetworkSimulator</a:t>
             </a:r>
-            <a:endParaRPr lang="en-US" b="1" dirty="0">
+            <a:endParaRPr lang="en-US" sz="1050" b="1" dirty="0">
               <a:solidFill>
                 <a:schemeClr val="tx1"/>
               </a:solidFill>
@@ -10343,8 +10462,8 @@
         </p:nvSpPr>
         <p:spPr>
           <a:xfrm>
-            <a:off x="1549400" y="2133600"/>
-            <a:ext cx="2882900" cy="838200"/>
+            <a:off x="2684039" y="2520137"/>
+            <a:ext cx="3004492" cy="603423"/>
           </a:xfrm>
           <a:prstGeom prst="rect">
             <a:avLst/>
@@ -10377,12 +10496,144 @@
           <a:lstStyle/>
           <a:p>
             <a:r>
-              <a:rPr lang="en-US" dirty="0">
+              <a:rPr lang="en-US" sz="1050" dirty="0">
                 <a:solidFill>
                   <a:schemeClr val="tx1"/>
                 </a:solidFill>
               </a:rPr>
-              <a:t>TODO</a:t>
+              <a:t>+run(system : </a:t>
+            </a:r>
+            <a:r>
+              <a:rPr lang="en-US" sz="1050" dirty="0" err="1">
+                <a:solidFill>
+                  <a:schemeClr val="tx1"/>
+                </a:solidFill>
+              </a:rPr>
+              <a:t>SimulatedSystem</a:t>
+            </a:r>
+            <a:r>
+              <a:rPr lang="en-US" sz="1050" dirty="0">
+                <a:solidFill>
+                  <a:schemeClr val="tx1"/>
+                </a:solidFill>
+              </a:rPr>
+              <a:t>, </a:t>
+            </a:r>
+            <a:r>
+              <a:rPr lang="en-US" sz="1050" dirty="0" err="1">
+                <a:solidFill>
+                  <a:schemeClr val="tx1"/>
+                </a:solidFill>
+              </a:rPr>
+              <a:t>t_delta</a:t>
+            </a:r>
+            <a:r>
+              <a:rPr lang="en-US" sz="1050" dirty="0">
+                <a:solidFill>
+                  <a:schemeClr val="tx1"/>
+                </a:solidFill>
+              </a:rPr>
+              <a:t> : float)</a:t>
+            </a:r>
+          </a:p>
+          <a:p>
+            <a:r>
+              <a:rPr lang="en-US" sz="1050" dirty="0">
+                <a:solidFill>
+                  <a:schemeClr val="tx1"/>
+                </a:solidFill>
+              </a:rPr>
+              <a:t>+</a:t>
+            </a:r>
+            <a:r>
+              <a:rPr lang="en-US" sz="1050" dirty="0" err="1">
+                <a:solidFill>
+                  <a:schemeClr val="tx1"/>
+                </a:solidFill>
+              </a:rPr>
+              <a:t>add_compute</a:t>
+            </a:r>
+            <a:r>
+              <a:rPr lang="en-US" sz="1050" dirty="0">
+                <a:solidFill>
+                  <a:schemeClr val="tx1"/>
+                </a:solidFill>
+              </a:rPr>
+              <a:t>(</a:t>
+            </a:r>
+            <a:r>
+              <a:rPr lang="en-US" sz="1050" dirty="0" err="1">
+                <a:solidFill>
+                  <a:schemeClr val="tx1"/>
+                </a:solidFill>
+              </a:rPr>
+              <a:t>compute_job</a:t>
+            </a:r>
+            <a:r>
+              <a:rPr lang="en-US" sz="1050" dirty="0">
+                <a:solidFill>
+                  <a:schemeClr val="tx1"/>
+                </a:solidFill>
+              </a:rPr>
+              <a:t> : </a:t>
+            </a:r>
+            <a:r>
+              <a:rPr lang="en-US" sz="1050" dirty="0" err="1">
+                <a:solidFill>
+                  <a:schemeClr val="tx1"/>
+                </a:solidFill>
+              </a:rPr>
+              <a:t>ComputeJob</a:t>
+            </a:r>
+            <a:r>
+              <a:rPr lang="en-US" sz="1050" dirty="0">
+                <a:solidFill>
+                  <a:schemeClr val="tx1"/>
+                </a:solidFill>
+              </a:rPr>
+              <a:t>)</a:t>
+            </a:r>
+          </a:p>
+          <a:p>
+            <a:r>
+              <a:rPr lang="en-US" sz="1050" dirty="0">
+                <a:solidFill>
+                  <a:schemeClr val="tx1"/>
+                </a:solidFill>
+              </a:rPr>
+              <a:t>+</a:t>
+            </a:r>
+            <a:r>
+              <a:rPr lang="en-US" sz="1050" dirty="0" err="1">
+                <a:solidFill>
+                  <a:schemeClr val="tx1"/>
+                </a:solidFill>
+              </a:rPr>
+              <a:t>add_batch</a:t>
+            </a:r>
+            <a:r>
+              <a:rPr lang="en-US" sz="1050" dirty="0">
+                <a:solidFill>
+                  <a:schemeClr val="tx1"/>
+                </a:solidFill>
+              </a:rPr>
+              <a:t>(batch : </a:t>
+            </a:r>
+            <a:r>
+              <a:rPr lang="en-US" sz="1050" dirty="0" err="1">
+                <a:solidFill>
+                  <a:schemeClr val="tx1"/>
+                </a:solidFill>
+              </a:rPr>
+              <a:t>DataBatch</a:t>
+            </a:r>
+            <a:r>
+              <a:rPr lang="en-US" sz="1050" dirty="0">
+                <a:solidFill>
+                  <a:schemeClr val="tx1"/>
+                </a:solidFill>
+              </a:rPr>
+              <a:t>)</a:t>
             </a:r>
           </a:p>
         </p:txBody>
@@ -10401,8 +10652,8 @@
         </p:nvSpPr>
         <p:spPr>
           <a:xfrm>
-            <a:off x="6477000" y="1465143"/>
-            <a:ext cx="2882900" cy="668457"/>
+            <a:off x="6622180" y="385720"/>
+            <a:ext cx="5284187" cy="383276"/>
           </a:xfrm>
           <a:prstGeom prst="rect">
             <a:avLst/>
@@ -10436,7 +10687,7 @@
           <a:p>
             <a:pPr algn="ctr"/>
             <a:r>
-              <a:rPr lang="en-US" dirty="0">
+              <a:rPr lang="en-US" sz="1050" dirty="0">
                 <a:solidFill>
                   <a:schemeClr val="tx1"/>
                 </a:solidFill>
@@ -10447,14 +10698,14 @@
           <a:p>
             <a:pPr algn="ctr"/>
             <a:r>
-              <a:rPr lang="en-US" b="1" dirty="0" err="1">
+              <a:rPr lang="en-US" sz="1050" b="1" dirty="0" err="1">
                 <a:solidFill>
                   <a:schemeClr val="tx1"/>
                 </a:solidFill>
               </a:rPr>
               <a:t>SimulatedSystem</a:t>
             </a:r>
-            <a:endParaRPr lang="en-US" b="1" dirty="0">
+            <a:endParaRPr lang="en-US" sz="1050" b="1" dirty="0">
               <a:solidFill>
                 <a:schemeClr val="tx1"/>
               </a:solidFill>
@@ -10476,8 +10727,8 @@
         </p:nvSpPr>
         <p:spPr>
           <a:xfrm>
-            <a:off x="6477000" y="2133600"/>
-            <a:ext cx="2882900" cy="838200"/>
+            <a:off x="6622180" y="768996"/>
+            <a:ext cx="5284187" cy="491884"/>
           </a:xfrm>
           <a:prstGeom prst="rect">
             <a:avLst/>
@@ -10510,12 +10761,2143 @@
           <a:lstStyle/>
           <a:p>
             <a:r>
-              <a:rPr lang="en-US" dirty="0">
+              <a:rPr lang="en-US" sz="1050" dirty="0">
                 <a:solidFill>
                   <a:schemeClr val="tx1"/>
                 </a:solidFill>
               </a:rPr>
-              <a:t>TODO</a:t>
+              <a:t>+</a:t>
+            </a:r>
+            <a:r>
+              <a:rPr lang="en-US" sz="1050" dirty="0" err="1">
+                <a:solidFill>
+                  <a:schemeClr val="tx1"/>
+                </a:solidFill>
+              </a:rPr>
+              <a:t>on_data_transfer_complete</a:t>
+            </a:r>
+            <a:r>
+              <a:rPr lang="en-US" sz="1050" dirty="0">
+                <a:solidFill>
+                  <a:schemeClr val="tx1"/>
+                </a:solidFill>
+              </a:rPr>
+              <a:t>(simulator : </a:t>
+            </a:r>
+            <a:r>
+              <a:rPr lang="en-US" sz="1050" dirty="0" err="1">
+                <a:solidFill>
+                  <a:schemeClr val="tx1"/>
+                </a:solidFill>
+              </a:rPr>
+              <a:t>CommNetworkSimulator</a:t>
+            </a:r>
+            <a:r>
+              <a:rPr lang="en-US" sz="1050" dirty="0">
+                <a:solidFill>
+                  <a:schemeClr val="tx1"/>
+                </a:solidFill>
+              </a:rPr>
+              <a:t>, batch : </a:t>
+            </a:r>
+            <a:r>
+              <a:rPr lang="en-US" sz="1050" dirty="0" err="1">
+                <a:solidFill>
+                  <a:schemeClr val="tx1"/>
+                </a:solidFill>
+              </a:rPr>
+              <a:t>DataBatch</a:t>
+            </a:r>
+            <a:r>
+              <a:rPr lang="en-US" sz="1050" dirty="0">
+                <a:solidFill>
+                  <a:schemeClr val="tx1"/>
+                </a:solidFill>
+              </a:rPr>
+              <a:t>)</a:t>
+            </a:r>
+          </a:p>
+          <a:p>
+            <a:r>
+              <a:rPr lang="en-US" sz="1050" dirty="0">
+                <a:solidFill>
+                  <a:schemeClr val="tx1"/>
+                </a:solidFill>
+              </a:rPr>
+              <a:t>+</a:t>
+            </a:r>
+            <a:r>
+              <a:rPr lang="en-US" sz="1050" dirty="0" err="1">
+                <a:solidFill>
+                  <a:schemeClr val="tx1"/>
+                </a:solidFill>
+              </a:rPr>
+              <a:t>on_compute_complete</a:t>
+            </a:r>
+            <a:r>
+              <a:rPr lang="en-US" sz="1050" dirty="0">
+                <a:solidFill>
+                  <a:schemeClr val="tx1"/>
+                </a:solidFill>
+              </a:rPr>
+              <a:t>(simulator : </a:t>
+            </a:r>
+            <a:r>
+              <a:rPr lang="en-US" sz="1050" dirty="0" err="1">
+                <a:solidFill>
+                  <a:schemeClr val="tx1"/>
+                </a:solidFill>
+              </a:rPr>
+              <a:t>CommNetworkSimulator</a:t>
+            </a:r>
+            <a:r>
+              <a:rPr lang="en-US" sz="1050" dirty="0">
+                <a:solidFill>
+                  <a:schemeClr val="tx1"/>
+                </a:solidFill>
+              </a:rPr>
+              <a:t>, </a:t>
+            </a:r>
+            <a:r>
+              <a:rPr lang="en-US" sz="1050" dirty="0" err="1">
+                <a:solidFill>
+                  <a:schemeClr val="tx1"/>
+                </a:solidFill>
+              </a:rPr>
+              <a:t>compute_job</a:t>
+            </a:r>
+            <a:r>
+              <a:rPr lang="en-US" sz="1050" dirty="0">
+                <a:solidFill>
+                  <a:schemeClr val="tx1"/>
+                </a:solidFill>
+              </a:rPr>
+              <a:t> : </a:t>
+            </a:r>
+            <a:r>
+              <a:rPr lang="en-US" sz="1050" dirty="0" err="1">
+                <a:solidFill>
+                  <a:schemeClr val="tx1"/>
+                </a:solidFill>
+              </a:rPr>
+              <a:t>ComputeJob</a:t>
+            </a:r>
+            <a:r>
+              <a:rPr lang="en-US" sz="1050" dirty="0">
+                <a:solidFill>
+                  <a:schemeClr val="tx1"/>
+                </a:solidFill>
+              </a:rPr>
+              <a:t>)</a:t>
+            </a:r>
+          </a:p>
+        </p:txBody>
+      </p:sp>
+      <p:sp>
+        <p:nvSpPr>
+          <p:cNvPr id="6" name="Rectangle 5">
+            <a:extLst>
+              <a:ext uri="{FF2B5EF4-FFF2-40B4-BE49-F238E27FC236}">
+                <a16:creationId xmlns:a16="http://schemas.microsoft.com/office/drawing/2014/main" id="{66483A18-8F83-17E7-33C5-2B1FA151E811}"/>
+              </a:ext>
+            </a:extLst>
+          </p:cNvPr>
+          <p:cNvSpPr/>
+          <p:nvPr/>
+        </p:nvSpPr>
+        <p:spPr>
+          <a:xfrm>
+            <a:off x="2109124" y="3771267"/>
+            <a:ext cx="1869831" cy="1279049"/>
+          </a:xfrm>
+          <a:prstGeom prst="rect">
+            <a:avLst/>
+          </a:prstGeom>
+          <a:noFill/>
+          <a:ln>
+            <a:solidFill>
+              <a:schemeClr val="tx1"/>
+            </a:solidFill>
+          </a:ln>
+        </p:spPr>
+        <p:style>
+          <a:lnRef idx="2">
+            <a:schemeClr val="accent1">
+              <a:shade val="15000"/>
+            </a:schemeClr>
+          </a:lnRef>
+          <a:fillRef idx="1">
+            <a:schemeClr val="accent1"/>
+          </a:fillRef>
+          <a:effectRef idx="0">
+            <a:schemeClr val="accent1"/>
+          </a:effectRef>
+          <a:fontRef idx="minor">
+            <a:schemeClr val="lt1"/>
+          </a:fontRef>
+        </p:style>
+        <p:txBody>
+          <a:bodyPr rtlCol="0" anchor="t"/>
+          <a:lstStyle/>
+          <a:p>
+            <a:r>
+              <a:rPr lang="en-US" sz="1050" dirty="0">
+                <a:solidFill>
+                  <a:schemeClr val="tx1"/>
+                </a:solidFill>
+              </a:rPr>
+              <a:t>+name : string</a:t>
+            </a:r>
+          </a:p>
+          <a:p>
+            <a:r>
+              <a:rPr lang="en-US" sz="1050" dirty="0">
+                <a:solidFill>
+                  <a:schemeClr val="tx1"/>
+                </a:solidFill>
+              </a:rPr>
+              <a:t>+</a:t>
+            </a:r>
+            <a:r>
+              <a:rPr lang="en-US" sz="1050" dirty="0" err="1">
+                <a:solidFill>
+                  <a:schemeClr val="tx1"/>
+                </a:solidFill>
+              </a:rPr>
+              <a:t>total_size</a:t>
+            </a:r>
+            <a:r>
+              <a:rPr lang="en-US" sz="1050" dirty="0">
+                <a:solidFill>
+                  <a:schemeClr val="tx1"/>
+                </a:solidFill>
+              </a:rPr>
+              <a:t> : float</a:t>
+            </a:r>
+          </a:p>
+          <a:p>
+            <a:r>
+              <a:rPr lang="en-US" sz="1050" dirty="0">
+                <a:solidFill>
+                  <a:schemeClr val="tx1"/>
+                </a:solidFill>
+              </a:rPr>
+              <a:t>+</a:t>
+            </a:r>
+            <a:r>
+              <a:rPr lang="en-US" sz="1050" dirty="0" err="1">
+                <a:solidFill>
+                  <a:schemeClr val="tx1"/>
+                </a:solidFill>
+              </a:rPr>
+              <a:t>rem_size</a:t>
+            </a:r>
+            <a:r>
+              <a:rPr lang="en-US" sz="1050" dirty="0">
+                <a:solidFill>
+                  <a:schemeClr val="tx1"/>
+                </a:solidFill>
+              </a:rPr>
+              <a:t> : float</a:t>
+            </a:r>
+          </a:p>
+          <a:p>
+            <a:r>
+              <a:rPr lang="en-US" sz="1050" dirty="0">
+                <a:solidFill>
+                  <a:schemeClr val="tx1"/>
+                </a:solidFill>
+              </a:rPr>
+              <a:t>+</a:t>
+            </a:r>
+            <a:r>
+              <a:rPr lang="en-US" sz="1050" dirty="0" err="1">
+                <a:solidFill>
+                  <a:schemeClr val="tx1"/>
+                </a:solidFill>
+              </a:rPr>
+              <a:t>total_latency</a:t>
+            </a:r>
+            <a:r>
+              <a:rPr lang="en-US" sz="1050" dirty="0">
+                <a:solidFill>
+                  <a:schemeClr val="tx1"/>
+                </a:solidFill>
+              </a:rPr>
+              <a:t> : float</a:t>
+            </a:r>
+          </a:p>
+          <a:p>
+            <a:r>
+              <a:rPr lang="en-US" sz="1050" dirty="0">
+                <a:solidFill>
+                  <a:schemeClr val="tx1"/>
+                </a:solidFill>
+              </a:rPr>
+              <a:t>+</a:t>
+            </a:r>
+            <a:r>
+              <a:rPr lang="en-US" sz="1050" dirty="0" err="1">
+                <a:solidFill>
+                  <a:schemeClr val="tx1"/>
+                </a:solidFill>
+              </a:rPr>
+              <a:t>latency_remaining</a:t>
+            </a:r>
+            <a:r>
+              <a:rPr lang="en-US" sz="1050" dirty="0">
+                <a:solidFill>
+                  <a:schemeClr val="tx1"/>
+                </a:solidFill>
+              </a:rPr>
+              <a:t> : float</a:t>
+            </a:r>
+          </a:p>
+          <a:p>
+            <a:r>
+              <a:rPr lang="en-US" sz="1050" dirty="0">
+                <a:solidFill>
+                  <a:schemeClr val="tx1"/>
+                </a:solidFill>
+              </a:rPr>
+              <a:t>+</a:t>
+            </a:r>
+            <a:r>
+              <a:rPr lang="en-US" sz="1050" dirty="0" err="1">
+                <a:solidFill>
+                  <a:schemeClr val="tx1"/>
+                </a:solidFill>
+              </a:rPr>
+              <a:t>start_time</a:t>
+            </a:r>
+            <a:r>
+              <a:rPr lang="en-US" sz="1050" dirty="0">
+                <a:solidFill>
+                  <a:schemeClr val="tx1"/>
+                </a:solidFill>
+              </a:rPr>
+              <a:t> : float</a:t>
+            </a:r>
+          </a:p>
+          <a:p>
+            <a:r>
+              <a:rPr lang="en-US" sz="1050" dirty="0">
+                <a:solidFill>
+                  <a:schemeClr val="tx1"/>
+                </a:solidFill>
+              </a:rPr>
+              <a:t>+</a:t>
+            </a:r>
+            <a:r>
+              <a:rPr lang="en-US" sz="1050" dirty="0" err="1">
+                <a:solidFill>
+                  <a:schemeClr val="tx1"/>
+                </a:solidFill>
+              </a:rPr>
+              <a:t>end_time</a:t>
+            </a:r>
+            <a:r>
+              <a:rPr lang="en-US" sz="1050" dirty="0">
+                <a:solidFill>
+                  <a:schemeClr val="tx1"/>
+                </a:solidFill>
+              </a:rPr>
+              <a:t> : float</a:t>
+            </a:r>
+          </a:p>
+        </p:txBody>
+      </p:sp>
+      <p:sp>
+        <p:nvSpPr>
+          <p:cNvPr id="7" name="Rectangle 6">
+            <a:extLst>
+              <a:ext uri="{FF2B5EF4-FFF2-40B4-BE49-F238E27FC236}">
+                <a16:creationId xmlns:a16="http://schemas.microsoft.com/office/drawing/2014/main" id="{523DF5A6-5A90-9D95-8461-45ACC8E44322}"/>
+              </a:ext>
+            </a:extLst>
+          </p:cNvPr>
+          <p:cNvSpPr/>
+          <p:nvPr/>
+        </p:nvSpPr>
+        <p:spPr>
+          <a:xfrm>
+            <a:off x="2226355" y="5465704"/>
+            <a:ext cx="1635369" cy="464280"/>
+          </a:xfrm>
+          <a:prstGeom prst="rect">
+            <a:avLst/>
+          </a:prstGeom>
+          <a:noFill/>
+          <a:ln>
+            <a:solidFill>
+              <a:schemeClr val="tx1"/>
+            </a:solidFill>
+          </a:ln>
+        </p:spPr>
+        <p:style>
+          <a:lnRef idx="2">
+            <a:schemeClr val="accent1">
+              <a:shade val="15000"/>
+            </a:schemeClr>
+          </a:lnRef>
+          <a:fillRef idx="1">
+            <a:schemeClr val="accent1"/>
+          </a:fillRef>
+          <a:effectRef idx="0">
+            <a:schemeClr val="accent1"/>
+          </a:effectRef>
+          <a:fontRef idx="minor">
+            <a:schemeClr val="lt1"/>
+          </a:fontRef>
+        </p:style>
+        <p:txBody>
+          <a:bodyPr rtlCol="0" anchor="ctr"/>
+          <a:lstStyle/>
+          <a:p>
+            <a:pPr algn="ctr"/>
+            <a:r>
+              <a:rPr lang="en-US" sz="1050" b="1" dirty="0" err="1">
+                <a:solidFill>
+                  <a:schemeClr val="tx1"/>
+                </a:solidFill>
+              </a:rPr>
+              <a:t>CommChannel</a:t>
+            </a:r>
+            <a:endParaRPr lang="en-US" sz="1050" b="1" dirty="0">
+              <a:solidFill>
+                <a:schemeClr val="tx1"/>
+              </a:solidFill>
+            </a:endParaRPr>
+          </a:p>
+        </p:txBody>
+      </p:sp>
+      <p:sp>
+        <p:nvSpPr>
+          <p:cNvPr id="8" name="Rectangle 7">
+            <a:extLst>
+              <a:ext uri="{FF2B5EF4-FFF2-40B4-BE49-F238E27FC236}">
+                <a16:creationId xmlns:a16="http://schemas.microsoft.com/office/drawing/2014/main" id="{5EFDEF02-B53E-4AAB-7EBE-D58F1CF39792}"/>
+              </a:ext>
+            </a:extLst>
+          </p:cNvPr>
+          <p:cNvSpPr/>
+          <p:nvPr/>
+        </p:nvSpPr>
+        <p:spPr>
+          <a:xfrm>
+            <a:off x="2226355" y="5938166"/>
+            <a:ext cx="1635369" cy="731475"/>
+          </a:xfrm>
+          <a:prstGeom prst="rect">
+            <a:avLst/>
+          </a:prstGeom>
+          <a:noFill/>
+          <a:ln>
+            <a:solidFill>
+              <a:schemeClr val="tx1"/>
+            </a:solidFill>
+          </a:ln>
+        </p:spPr>
+        <p:style>
+          <a:lnRef idx="2">
+            <a:schemeClr val="accent1">
+              <a:shade val="15000"/>
+            </a:schemeClr>
+          </a:lnRef>
+          <a:fillRef idx="1">
+            <a:schemeClr val="accent1"/>
+          </a:fillRef>
+          <a:effectRef idx="0">
+            <a:schemeClr val="accent1"/>
+          </a:effectRef>
+          <a:fontRef idx="minor">
+            <a:schemeClr val="lt1"/>
+          </a:fontRef>
+        </p:style>
+        <p:txBody>
+          <a:bodyPr rtlCol="0" anchor="t"/>
+          <a:lstStyle/>
+          <a:p>
+            <a:r>
+              <a:rPr lang="en-US" sz="1050" dirty="0">
+                <a:solidFill>
+                  <a:schemeClr val="tx1"/>
+                </a:solidFill>
+              </a:rPr>
+              <a:t>+name : string</a:t>
+            </a:r>
+          </a:p>
+          <a:p>
+            <a:r>
+              <a:rPr lang="en-US" sz="1050" dirty="0">
+                <a:solidFill>
+                  <a:schemeClr val="tx1"/>
+                </a:solidFill>
+              </a:rPr>
+              <a:t>+</a:t>
+            </a:r>
+            <a:r>
+              <a:rPr lang="en-US" sz="1050" dirty="0" err="1">
+                <a:solidFill>
+                  <a:schemeClr val="tx1"/>
+                </a:solidFill>
+              </a:rPr>
+              <a:t>bw_gbps</a:t>
+            </a:r>
+            <a:r>
+              <a:rPr lang="en-US" sz="1050" dirty="0">
+                <a:solidFill>
+                  <a:schemeClr val="tx1"/>
+                </a:solidFill>
+              </a:rPr>
+              <a:t> : float</a:t>
+            </a:r>
+          </a:p>
+          <a:p>
+            <a:r>
+              <a:rPr lang="en-US" sz="1050" dirty="0">
+                <a:solidFill>
+                  <a:schemeClr val="tx1"/>
+                </a:solidFill>
+              </a:rPr>
+              <a:t>+</a:t>
+            </a:r>
+            <a:r>
+              <a:rPr lang="en-US" sz="1050" dirty="0" err="1">
+                <a:solidFill>
+                  <a:schemeClr val="tx1"/>
+                </a:solidFill>
+              </a:rPr>
+              <a:t>lat_us</a:t>
+            </a:r>
+            <a:r>
+              <a:rPr lang="en-US" sz="1050" dirty="0">
+                <a:solidFill>
+                  <a:schemeClr val="tx1"/>
+                </a:solidFill>
+              </a:rPr>
+              <a:t> : float</a:t>
+            </a:r>
+          </a:p>
+        </p:txBody>
+      </p:sp>
+      <p:sp>
+        <p:nvSpPr>
+          <p:cNvPr id="12" name="Rectangle 11">
+            <a:extLst>
+              <a:ext uri="{FF2B5EF4-FFF2-40B4-BE49-F238E27FC236}">
+                <a16:creationId xmlns:a16="http://schemas.microsoft.com/office/drawing/2014/main" id="{3E59D4DC-8680-49A4-6D7F-84987D831FB2}"/>
+              </a:ext>
+            </a:extLst>
+          </p:cNvPr>
+          <p:cNvSpPr/>
+          <p:nvPr/>
+        </p:nvSpPr>
+        <p:spPr>
+          <a:xfrm>
+            <a:off x="2109124" y="3298805"/>
+            <a:ext cx="1869831" cy="464280"/>
+          </a:xfrm>
+          <a:prstGeom prst="rect">
+            <a:avLst/>
+          </a:prstGeom>
+          <a:noFill/>
+          <a:ln>
+            <a:solidFill>
+              <a:schemeClr val="tx1"/>
+            </a:solidFill>
+          </a:ln>
+        </p:spPr>
+        <p:style>
+          <a:lnRef idx="2">
+            <a:schemeClr val="accent1">
+              <a:shade val="15000"/>
+            </a:schemeClr>
+          </a:lnRef>
+          <a:fillRef idx="1">
+            <a:schemeClr val="accent1"/>
+          </a:fillRef>
+          <a:effectRef idx="0">
+            <a:schemeClr val="accent1"/>
+          </a:effectRef>
+          <a:fontRef idx="minor">
+            <a:schemeClr val="lt1"/>
+          </a:fontRef>
+        </p:style>
+        <p:txBody>
+          <a:bodyPr rtlCol="0" anchor="ctr"/>
+          <a:lstStyle/>
+          <a:p>
+            <a:pPr algn="ctr"/>
+            <a:r>
+              <a:rPr lang="en-US" sz="1050" b="1" dirty="0" err="1">
+                <a:solidFill>
+                  <a:schemeClr val="tx1"/>
+                </a:solidFill>
+              </a:rPr>
+              <a:t>DataBatch</a:t>
+            </a:r>
+            <a:endParaRPr lang="en-US" sz="1050" b="1" dirty="0">
+              <a:solidFill>
+                <a:schemeClr val="tx1"/>
+              </a:solidFill>
+            </a:endParaRPr>
+          </a:p>
+        </p:txBody>
+      </p:sp>
+      <p:sp>
+        <p:nvSpPr>
+          <p:cNvPr id="15" name="TextBox 14">
+            <a:extLst>
+              <a:ext uri="{FF2B5EF4-FFF2-40B4-BE49-F238E27FC236}">
+                <a16:creationId xmlns:a16="http://schemas.microsoft.com/office/drawing/2014/main" id="{3DA01819-9188-44CD-9A07-0EB5697670CA}"/>
+              </a:ext>
+            </a:extLst>
+          </p:cNvPr>
+          <p:cNvSpPr txBox="1"/>
+          <p:nvPr/>
+        </p:nvSpPr>
+        <p:spPr>
+          <a:xfrm>
+            <a:off x="2527552" y="5195912"/>
+            <a:ext cx="516487" cy="261610"/>
+          </a:xfrm>
+          <a:prstGeom prst="rect">
+            <a:avLst/>
+          </a:prstGeom>
+          <a:noFill/>
+        </p:spPr>
+        <p:txBody>
+          <a:bodyPr wrap="none" rtlCol="0">
+            <a:spAutoFit/>
+          </a:bodyPr>
+          <a:lstStyle/>
+          <a:p>
+            <a:pPr algn="r"/>
+            <a:r>
+              <a:rPr lang="en-US" sz="1050" dirty="0"/>
+              <a:t>+path</a:t>
+            </a:r>
+          </a:p>
+        </p:txBody>
+      </p:sp>
+      <p:cxnSp>
+        <p:nvCxnSpPr>
+          <p:cNvPr id="19" name="Connector: Elbow 18">
+            <a:extLst>
+              <a:ext uri="{FF2B5EF4-FFF2-40B4-BE49-F238E27FC236}">
+                <a16:creationId xmlns:a16="http://schemas.microsoft.com/office/drawing/2014/main" id="{EDC6FFA8-A1E1-9949-E5B1-EE47FC6D813C}"/>
+              </a:ext>
+            </a:extLst>
+          </p:cNvPr>
+          <p:cNvCxnSpPr>
+            <a:cxnSpLocks/>
+            <a:stCxn id="5" idx="1"/>
+            <a:endCxn id="12" idx="1"/>
+          </p:cNvCxnSpPr>
+          <p:nvPr/>
+        </p:nvCxnSpPr>
+        <p:spPr>
+          <a:xfrm rot="10800000" flipV="1">
+            <a:off x="2109125" y="2821849"/>
+            <a:ext cx="574915" cy="709096"/>
+          </a:xfrm>
+          <a:prstGeom prst="bentConnector3">
+            <a:avLst>
+              <a:gd name="adj1" fmla="val 139762"/>
+            </a:avLst>
+          </a:prstGeom>
+          <a:ln>
+            <a:solidFill>
+              <a:schemeClr val="tx1"/>
+            </a:solidFill>
+            <a:headEnd type="diamond" w="lg" len="lg"/>
+            <a:tailEnd type="arrow" w="lg" len="lg"/>
+          </a:ln>
+        </p:spPr>
+        <p:style>
+          <a:lnRef idx="2">
+            <a:schemeClr val="accent1"/>
+          </a:lnRef>
+          <a:fillRef idx="0">
+            <a:schemeClr val="accent1"/>
+          </a:fillRef>
+          <a:effectRef idx="1">
+            <a:schemeClr val="accent1"/>
+          </a:effectRef>
+          <a:fontRef idx="minor">
+            <a:schemeClr val="tx1"/>
+          </a:fontRef>
+        </p:style>
+      </p:cxnSp>
+      <p:cxnSp>
+        <p:nvCxnSpPr>
+          <p:cNvPr id="24" name="Connector: Elbow 23">
+            <a:extLst>
+              <a:ext uri="{FF2B5EF4-FFF2-40B4-BE49-F238E27FC236}">
+                <a16:creationId xmlns:a16="http://schemas.microsoft.com/office/drawing/2014/main" id="{314881B4-7EAE-96FC-E4A2-1FEFB1129D3C}"/>
+              </a:ext>
+            </a:extLst>
+          </p:cNvPr>
+          <p:cNvCxnSpPr>
+            <a:cxnSpLocks/>
+            <a:stCxn id="2" idx="1"/>
+            <a:endCxn id="6" idx="1"/>
+          </p:cNvCxnSpPr>
+          <p:nvPr/>
+        </p:nvCxnSpPr>
+        <p:spPr>
+          <a:xfrm rot="10800000" flipV="1">
+            <a:off x="2109125" y="1939054"/>
+            <a:ext cx="574915" cy="2471738"/>
+          </a:xfrm>
+          <a:prstGeom prst="bentConnector3">
+            <a:avLst>
+              <a:gd name="adj1" fmla="val 357409"/>
+            </a:avLst>
+          </a:prstGeom>
+          <a:ln>
+            <a:solidFill>
+              <a:schemeClr val="tx1"/>
+            </a:solidFill>
+            <a:headEnd type="diamond" w="lg" len="lg"/>
+            <a:tailEnd type="arrow" w="lg" len="lg"/>
+          </a:ln>
+        </p:spPr>
+        <p:style>
+          <a:lnRef idx="2">
+            <a:schemeClr val="accent1"/>
+          </a:lnRef>
+          <a:fillRef idx="0">
+            <a:schemeClr val="accent1"/>
+          </a:fillRef>
+          <a:effectRef idx="1">
+            <a:schemeClr val="accent1"/>
+          </a:effectRef>
+          <a:fontRef idx="minor">
+            <a:schemeClr val="tx1"/>
+          </a:fontRef>
+        </p:style>
+      </p:cxnSp>
+      <p:sp>
+        <p:nvSpPr>
+          <p:cNvPr id="27" name="TextBox 26">
+            <a:extLst>
+              <a:ext uri="{FF2B5EF4-FFF2-40B4-BE49-F238E27FC236}">
+                <a16:creationId xmlns:a16="http://schemas.microsoft.com/office/drawing/2014/main" id="{CC111928-4044-6D59-2689-E7BD056C02FA}"/>
+              </a:ext>
+            </a:extLst>
+          </p:cNvPr>
+          <p:cNvSpPr txBox="1"/>
+          <p:nvPr/>
+        </p:nvSpPr>
+        <p:spPr>
+          <a:xfrm>
+            <a:off x="997922" y="3530944"/>
+            <a:ext cx="1111202" cy="261610"/>
+          </a:xfrm>
+          <a:prstGeom prst="rect">
+            <a:avLst/>
+          </a:prstGeom>
+          <a:noFill/>
+        </p:spPr>
+        <p:txBody>
+          <a:bodyPr wrap="none" rtlCol="0">
+            <a:spAutoFit/>
+          </a:bodyPr>
+          <a:lstStyle/>
+          <a:p>
+            <a:pPr algn="r"/>
+            <a:r>
+              <a:rPr lang="en-US" sz="1050" dirty="0"/>
+              <a:t>+</a:t>
+            </a:r>
+            <a:r>
+              <a:rPr lang="en-US" sz="1050" dirty="0" err="1"/>
+              <a:t>active_batches</a:t>
+            </a:r>
+            <a:endParaRPr lang="en-US" sz="1050" dirty="0"/>
+          </a:p>
+        </p:txBody>
+      </p:sp>
+      <p:sp>
+        <p:nvSpPr>
+          <p:cNvPr id="43" name="TextBox 42">
+            <a:extLst>
+              <a:ext uri="{FF2B5EF4-FFF2-40B4-BE49-F238E27FC236}">
+                <a16:creationId xmlns:a16="http://schemas.microsoft.com/office/drawing/2014/main" id="{18E3DE83-2C0D-9870-02C0-BE8E0F5FEE8D}"/>
+              </a:ext>
+            </a:extLst>
+          </p:cNvPr>
+          <p:cNvSpPr txBox="1"/>
+          <p:nvPr/>
+        </p:nvSpPr>
+        <p:spPr>
+          <a:xfrm>
+            <a:off x="696434" y="4410791"/>
+            <a:ext cx="1383712" cy="261610"/>
+          </a:xfrm>
+          <a:prstGeom prst="rect">
+            <a:avLst/>
+          </a:prstGeom>
+          <a:noFill/>
+        </p:spPr>
+        <p:txBody>
+          <a:bodyPr wrap="none" rtlCol="0">
+            <a:spAutoFit/>
+          </a:bodyPr>
+          <a:lstStyle/>
+          <a:p>
+            <a:pPr algn="r"/>
+            <a:r>
+              <a:rPr lang="en-US" sz="1050" dirty="0"/>
+              <a:t>+</a:t>
+            </a:r>
+            <a:r>
+              <a:rPr lang="en-US" sz="1050" dirty="0" err="1"/>
+              <a:t>completed_batches</a:t>
+            </a:r>
+            <a:endParaRPr lang="en-US" sz="1050" dirty="0"/>
+          </a:p>
+        </p:txBody>
+      </p:sp>
+      <p:sp>
+        <p:nvSpPr>
+          <p:cNvPr id="55" name="Rectangle 54">
+            <a:extLst>
+              <a:ext uri="{FF2B5EF4-FFF2-40B4-BE49-F238E27FC236}">
+                <a16:creationId xmlns:a16="http://schemas.microsoft.com/office/drawing/2014/main" id="{BF788B48-F0D0-3BE4-F4C4-6314A772CFA2}"/>
+              </a:ext>
+            </a:extLst>
+          </p:cNvPr>
+          <p:cNvSpPr/>
+          <p:nvPr/>
+        </p:nvSpPr>
+        <p:spPr>
+          <a:xfrm>
+            <a:off x="4504210" y="3763085"/>
+            <a:ext cx="1869831" cy="1279049"/>
+          </a:xfrm>
+          <a:prstGeom prst="rect">
+            <a:avLst/>
+          </a:prstGeom>
+          <a:noFill/>
+          <a:ln>
+            <a:solidFill>
+              <a:schemeClr val="tx1"/>
+            </a:solidFill>
+          </a:ln>
+        </p:spPr>
+        <p:style>
+          <a:lnRef idx="2">
+            <a:schemeClr val="accent1">
+              <a:shade val="15000"/>
+            </a:schemeClr>
+          </a:lnRef>
+          <a:fillRef idx="1">
+            <a:schemeClr val="accent1"/>
+          </a:fillRef>
+          <a:effectRef idx="0">
+            <a:schemeClr val="accent1"/>
+          </a:effectRef>
+          <a:fontRef idx="minor">
+            <a:schemeClr val="lt1"/>
+          </a:fontRef>
+        </p:style>
+        <p:txBody>
+          <a:bodyPr rtlCol="0" anchor="t"/>
+          <a:lstStyle/>
+          <a:p>
+            <a:r>
+              <a:rPr lang="en-US" sz="1050" dirty="0">
+                <a:solidFill>
+                  <a:schemeClr val="tx1"/>
+                </a:solidFill>
+              </a:rPr>
+              <a:t>+name : string</a:t>
+            </a:r>
+          </a:p>
+          <a:p>
+            <a:r>
+              <a:rPr lang="en-US" sz="1050" dirty="0">
+                <a:solidFill>
+                  <a:schemeClr val="tx1"/>
+                </a:solidFill>
+              </a:rPr>
+              <a:t>+</a:t>
+            </a:r>
+            <a:r>
+              <a:rPr lang="en-US" sz="1050" dirty="0" err="1">
+                <a:solidFill>
+                  <a:schemeClr val="tx1"/>
+                </a:solidFill>
+              </a:rPr>
+              <a:t>total_duration</a:t>
+            </a:r>
+            <a:r>
+              <a:rPr lang="en-US" sz="1050" dirty="0">
+                <a:solidFill>
+                  <a:schemeClr val="tx1"/>
+                </a:solidFill>
+              </a:rPr>
+              <a:t> : float</a:t>
+            </a:r>
+          </a:p>
+          <a:p>
+            <a:r>
+              <a:rPr lang="en-US" sz="1050" dirty="0">
+                <a:solidFill>
+                  <a:schemeClr val="tx1"/>
+                </a:solidFill>
+              </a:rPr>
+              <a:t>+</a:t>
+            </a:r>
+            <a:r>
+              <a:rPr lang="en-US" sz="1050" dirty="0" err="1">
+                <a:solidFill>
+                  <a:schemeClr val="tx1"/>
+                </a:solidFill>
+              </a:rPr>
+              <a:t>rem_duration</a:t>
+            </a:r>
+            <a:r>
+              <a:rPr lang="en-US" sz="1050" dirty="0">
+                <a:solidFill>
+                  <a:schemeClr val="tx1"/>
+                </a:solidFill>
+              </a:rPr>
+              <a:t> : float</a:t>
+            </a:r>
+          </a:p>
+          <a:p>
+            <a:r>
+              <a:rPr lang="en-US" sz="1050" dirty="0">
+                <a:solidFill>
+                  <a:schemeClr val="tx1"/>
+                </a:solidFill>
+              </a:rPr>
+              <a:t>+</a:t>
+            </a:r>
+            <a:r>
+              <a:rPr lang="en-US" sz="1050" dirty="0" err="1">
+                <a:solidFill>
+                  <a:schemeClr val="tx1"/>
+                </a:solidFill>
+              </a:rPr>
+              <a:t>start_time</a:t>
+            </a:r>
+            <a:r>
+              <a:rPr lang="en-US" sz="1050" dirty="0">
+                <a:solidFill>
+                  <a:schemeClr val="tx1"/>
+                </a:solidFill>
+              </a:rPr>
+              <a:t> : float</a:t>
+            </a:r>
+          </a:p>
+          <a:p>
+            <a:r>
+              <a:rPr lang="en-US" sz="1050" dirty="0">
+                <a:solidFill>
+                  <a:schemeClr val="tx1"/>
+                </a:solidFill>
+              </a:rPr>
+              <a:t>+</a:t>
+            </a:r>
+            <a:r>
+              <a:rPr lang="en-US" sz="1050" dirty="0" err="1">
+                <a:solidFill>
+                  <a:schemeClr val="tx1"/>
+                </a:solidFill>
+              </a:rPr>
+              <a:t>end_time</a:t>
+            </a:r>
+            <a:r>
+              <a:rPr lang="en-US" sz="1050" dirty="0">
+                <a:solidFill>
+                  <a:schemeClr val="tx1"/>
+                </a:solidFill>
+              </a:rPr>
+              <a:t> : float</a:t>
+            </a:r>
+          </a:p>
+        </p:txBody>
+      </p:sp>
+      <p:sp>
+        <p:nvSpPr>
+          <p:cNvPr id="56" name="Rectangle 55">
+            <a:extLst>
+              <a:ext uri="{FF2B5EF4-FFF2-40B4-BE49-F238E27FC236}">
+                <a16:creationId xmlns:a16="http://schemas.microsoft.com/office/drawing/2014/main" id="{B10689FF-983C-BD27-EC0A-EE4BB4F1C710}"/>
+              </a:ext>
+            </a:extLst>
+          </p:cNvPr>
+          <p:cNvSpPr/>
+          <p:nvPr/>
+        </p:nvSpPr>
+        <p:spPr>
+          <a:xfrm>
+            <a:off x="4504210" y="3290623"/>
+            <a:ext cx="1869831" cy="464280"/>
+          </a:xfrm>
+          <a:prstGeom prst="rect">
+            <a:avLst/>
+          </a:prstGeom>
+          <a:noFill/>
+          <a:ln>
+            <a:solidFill>
+              <a:schemeClr val="tx1"/>
+            </a:solidFill>
+          </a:ln>
+        </p:spPr>
+        <p:style>
+          <a:lnRef idx="2">
+            <a:schemeClr val="accent1">
+              <a:shade val="15000"/>
+            </a:schemeClr>
+          </a:lnRef>
+          <a:fillRef idx="1">
+            <a:schemeClr val="accent1"/>
+          </a:fillRef>
+          <a:effectRef idx="0">
+            <a:schemeClr val="accent1"/>
+          </a:effectRef>
+          <a:fontRef idx="minor">
+            <a:schemeClr val="lt1"/>
+          </a:fontRef>
+        </p:style>
+        <p:txBody>
+          <a:bodyPr rtlCol="0" anchor="ctr"/>
+          <a:lstStyle/>
+          <a:p>
+            <a:pPr algn="ctr"/>
+            <a:r>
+              <a:rPr lang="en-US" sz="1050" b="1" dirty="0" err="1">
+                <a:solidFill>
+                  <a:schemeClr val="tx1"/>
+                </a:solidFill>
+              </a:rPr>
+              <a:t>ComputeJob</a:t>
+            </a:r>
+            <a:endParaRPr lang="en-US" sz="1050" b="1" dirty="0">
+              <a:solidFill>
+                <a:schemeClr val="tx1"/>
+              </a:solidFill>
+            </a:endParaRPr>
+          </a:p>
+        </p:txBody>
+      </p:sp>
+      <p:cxnSp>
+        <p:nvCxnSpPr>
+          <p:cNvPr id="60" name="Connector: Elbow 59">
+            <a:extLst>
+              <a:ext uri="{FF2B5EF4-FFF2-40B4-BE49-F238E27FC236}">
+                <a16:creationId xmlns:a16="http://schemas.microsoft.com/office/drawing/2014/main" id="{45093D5C-2494-0947-C36C-37F4B229664C}"/>
+              </a:ext>
+            </a:extLst>
+          </p:cNvPr>
+          <p:cNvCxnSpPr>
+            <a:cxnSpLocks/>
+            <a:stCxn id="2" idx="3"/>
+            <a:endCxn id="55" idx="3"/>
+          </p:cNvCxnSpPr>
+          <p:nvPr/>
+        </p:nvCxnSpPr>
+        <p:spPr>
+          <a:xfrm>
+            <a:off x="5688531" y="1939054"/>
+            <a:ext cx="685510" cy="2463556"/>
+          </a:xfrm>
+          <a:prstGeom prst="bentConnector3">
+            <a:avLst>
+              <a:gd name="adj1" fmla="val 311668"/>
+            </a:avLst>
+          </a:prstGeom>
+          <a:ln>
+            <a:solidFill>
+              <a:schemeClr val="tx1"/>
+            </a:solidFill>
+            <a:headEnd type="diamond" w="lg" len="lg"/>
+            <a:tailEnd type="arrow" w="lg" len="lg"/>
+          </a:ln>
+        </p:spPr>
+        <p:style>
+          <a:lnRef idx="2">
+            <a:schemeClr val="accent1"/>
+          </a:lnRef>
+          <a:fillRef idx="0">
+            <a:schemeClr val="accent1"/>
+          </a:fillRef>
+          <a:effectRef idx="1">
+            <a:schemeClr val="accent1"/>
+          </a:effectRef>
+          <a:fontRef idx="minor">
+            <a:schemeClr val="tx1"/>
+          </a:fontRef>
+        </p:style>
+      </p:cxnSp>
+      <p:cxnSp>
+        <p:nvCxnSpPr>
+          <p:cNvPr id="63" name="Connector: Elbow 62">
+            <a:extLst>
+              <a:ext uri="{FF2B5EF4-FFF2-40B4-BE49-F238E27FC236}">
+                <a16:creationId xmlns:a16="http://schemas.microsoft.com/office/drawing/2014/main" id="{386F14F0-208D-9DF4-C803-3F15AAC5A860}"/>
+              </a:ext>
+            </a:extLst>
+          </p:cNvPr>
+          <p:cNvCxnSpPr>
+            <a:cxnSpLocks/>
+            <a:stCxn id="5" idx="3"/>
+            <a:endCxn id="56" idx="3"/>
+          </p:cNvCxnSpPr>
+          <p:nvPr/>
+        </p:nvCxnSpPr>
+        <p:spPr>
+          <a:xfrm>
+            <a:off x="5688531" y="2821849"/>
+            <a:ext cx="685510" cy="700914"/>
+          </a:xfrm>
+          <a:prstGeom prst="bentConnector3">
+            <a:avLst>
+              <a:gd name="adj1" fmla="val 133347"/>
+            </a:avLst>
+          </a:prstGeom>
+          <a:ln>
+            <a:solidFill>
+              <a:schemeClr val="tx1"/>
+            </a:solidFill>
+            <a:headEnd type="diamond" w="lg" len="lg"/>
+            <a:tailEnd type="arrow" w="lg" len="lg"/>
+          </a:ln>
+        </p:spPr>
+        <p:style>
+          <a:lnRef idx="2">
+            <a:schemeClr val="accent1"/>
+          </a:lnRef>
+          <a:fillRef idx="0">
+            <a:schemeClr val="accent1"/>
+          </a:fillRef>
+          <a:effectRef idx="1">
+            <a:schemeClr val="accent1"/>
+          </a:effectRef>
+          <a:fontRef idx="minor">
+            <a:schemeClr val="tx1"/>
+          </a:fontRef>
+        </p:style>
+      </p:cxnSp>
+      <p:sp>
+        <p:nvSpPr>
+          <p:cNvPr id="67" name="TextBox 66">
+            <a:extLst>
+              <a:ext uri="{FF2B5EF4-FFF2-40B4-BE49-F238E27FC236}">
+                <a16:creationId xmlns:a16="http://schemas.microsoft.com/office/drawing/2014/main" id="{9A41B717-63C0-A7AC-84A8-B22B886C07CE}"/>
+              </a:ext>
+            </a:extLst>
+          </p:cNvPr>
+          <p:cNvSpPr txBox="1"/>
+          <p:nvPr/>
+        </p:nvSpPr>
+        <p:spPr>
+          <a:xfrm>
+            <a:off x="6374041" y="3522763"/>
+            <a:ext cx="1133644" cy="253916"/>
+          </a:xfrm>
+          <a:prstGeom prst="rect">
+            <a:avLst/>
+          </a:prstGeom>
+          <a:noFill/>
+        </p:spPr>
+        <p:txBody>
+          <a:bodyPr wrap="none" rtlCol="0">
+            <a:spAutoFit/>
+          </a:bodyPr>
+          <a:lstStyle/>
+          <a:p>
+            <a:r>
+              <a:rPr lang="en-US" sz="1050" dirty="0"/>
+              <a:t>+</a:t>
+            </a:r>
+            <a:r>
+              <a:rPr lang="en-US" sz="1050" dirty="0" err="1"/>
+              <a:t>active_compute</a:t>
+            </a:r>
+            <a:endParaRPr lang="en-US" sz="1050" dirty="0"/>
+          </a:p>
+        </p:txBody>
+      </p:sp>
+      <p:sp>
+        <p:nvSpPr>
+          <p:cNvPr id="68" name="TextBox 67">
+            <a:extLst>
+              <a:ext uri="{FF2B5EF4-FFF2-40B4-BE49-F238E27FC236}">
+                <a16:creationId xmlns:a16="http://schemas.microsoft.com/office/drawing/2014/main" id="{4EC1E884-4BA5-5219-EF1D-DE6322754DB6}"/>
+              </a:ext>
+            </a:extLst>
+          </p:cNvPr>
+          <p:cNvSpPr txBox="1"/>
+          <p:nvPr/>
+        </p:nvSpPr>
+        <p:spPr>
+          <a:xfrm>
+            <a:off x="6374041" y="4402610"/>
+            <a:ext cx="1394934" cy="253916"/>
+          </a:xfrm>
+          <a:prstGeom prst="rect">
+            <a:avLst/>
+          </a:prstGeom>
+          <a:noFill/>
+        </p:spPr>
+        <p:txBody>
+          <a:bodyPr wrap="none" rtlCol="0">
+            <a:spAutoFit/>
+          </a:bodyPr>
+          <a:lstStyle/>
+          <a:p>
+            <a:r>
+              <a:rPr lang="en-US" sz="1050" dirty="0"/>
+              <a:t>+</a:t>
+            </a:r>
+            <a:r>
+              <a:rPr lang="en-US" sz="1050" dirty="0" err="1"/>
+              <a:t>completed_compute</a:t>
+            </a:r>
+            <a:endParaRPr lang="en-US" sz="1050" dirty="0"/>
+          </a:p>
+        </p:txBody>
+      </p:sp>
+      <p:cxnSp>
+        <p:nvCxnSpPr>
+          <p:cNvPr id="70" name="Connector: Elbow 69">
+            <a:extLst>
+              <a:ext uri="{FF2B5EF4-FFF2-40B4-BE49-F238E27FC236}">
+                <a16:creationId xmlns:a16="http://schemas.microsoft.com/office/drawing/2014/main" id="{88CB168B-A073-7E89-B9DB-25219AA56D5B}"/>
+              </a:ext>
+            </a:extLst>
+          </p:cNvPr>
+          <p:cNvCxnSpPr>
+            <a:cxnSpLocks/>
+            <a:stCxn id="2" idx="0"/>
+            <a:endCxn id="14" idx="1"/>
+          </p:cNvCxnSpPr>
+          <p:nvPr/>
+        </p:nvCxnSpPr>
+        <p:spPr>
+          <a:xfrm rot="5400000" flipH="1" flipV="1">
+            <a:off x="4819203" y="-55560"/>
+            <a:ext cx="1170058" cy="2435895"/>
+          </a:xfrm>
+          <a:prstGeom prst="bentConnector2">
+            <a:avLst/>
+          </a:prstGeom>
+          <a:ln>
+            <a:solidFill>
+              <a:schemeClr val="tx1"/>
+            </a:solidFill>
+            <a:prstDash val="dash"/>
+          </a:ln>
+        </p:spPr>
+        <p:style>
+          <a:lnRef idx="2">
+            <a:schemeClr val="accent1"/>
+          </a:lnRef>
+          <a:fillRef idx="0">
+            <a:schemeClr val="accent1"/>
+          </a:fillRef>
+          <a:effectRef idx="1">
+            <a:schemeClr val="accent1"/>
+          </a:effectRef>
+          <a:fontRef idx="minor">
+            <a:schemeClr val="tx1"/>
+          </a:fontRef>
+        </p:style>
+      </p:cxnSp>
+      <p:sp>
+        <p:nvSpPr>
+          <p:cNvPr id="82" name="Rectangle 81">
+            <a:extLst>
+              <a:ext uri="{FF2B5EF4-FFF2-40B4-BE49-F238E27FC236}">
+                <a16:creationId xmlns:a16="http://schemas.microsoft.com/office/drawing/2014/main" id="{14E06FB1-35A8-D73C-4238-3FA69A3B5A57}"/>
+              </a:ext>
+            </a:extLst>
+          </p:cNvPr>
+          <p:cNvSpPr/>
+          <p:nvPr/>
+        </p:nvSpPr>
+        <p:spPr>
+          <a:xfrm>
+            <a:off x="8193196" y="2734115"/>
+            <a:ext cx="2686656" cy="383276"/>
+          </a:xfrm>
+          <a:prstGeom prst="rect">
+            <a:avLst/>
+          </a:prstGeom>
+          <a:noFill/>
+          <a:ln>
+            <a:solidFill>
+              <a:schemeClr val="tx1"/>
+            </a:solidFill>
+          </a:ln>
+        </p:spPr>
+        <p:style>
+          <a:lnRef idx="2">
+            <a:schemeClr val="accent1">
+              <a:shade val="15000"/>
+            </a:schemeClr>
+          </a:lnRef>
+          <a:fillRef idx="1">
+            <a:schemeClr val="accent1"/>
+          </a:fillRef>
+          <a:effectRef idx="0">
+            <a:schemeClr val="accent1"/>
+          </a:effectRef>
+          <a:fontRef idx="minor">
+            <a:schemeClr val="lt1"/>
+          </a:fontRef>
+        </p:style>
+        <p:txBody>
+          <a:bodyPr rtlCol="0" anchor="ctr"/>
+          <a:lstStyle/>
+          <a:p>
+            <a:pPr algn="ctr"/>
+            <a:r>
+              <a:rPr lang="en-US" sz="1050" b="1" dirty="0" err="1">
+                <a:solidFill>
+                  <a:schemeClr val="tx1"/>
+                </a:solidFill>
+              </a:rPr>
+              <a:t>ConcreteSimulatedSystem</a:t>
+            </a:r>
+            <a:endParaRPr lang="en-US" sz="1050" b="1" dirty="0">
+              <a:solidFill>
+                <a:schemeClr val="tx1"/>
+              </a:solidFill>
+            </a:endParaRPr>
+          </a:p>
+        </p:txBody>
+      </p:sp>
+      <p:cxnSp>
+        <p:nvCxnSpPr>
+          <p:cNvPr id="85" name="Connector: Elbow 84">
+            <a:extLst>
+              <a:ext uri="{FF2B5EF4-FFF2-40B4-BE49-F238E27FC236}">
+                <a16:creationId xmlns:a16="http://schemas.microsoft.com/office/drawing/2014/main" id="{8CA42019-F0B5-2573-40E1-839829E791BE}"/>
+              </a:ext>
+            </a:extLst>
+          </p:cNvPr>
+          <p:cNvCxnSpPr>
+            <a:cxnSpLocks/>
+            <a:stCxn id="82" idx="0"/>
+            <a:endCxn id="17" idx="2"/>
+          </p:cNvCxnSpPr>
+          <p:nvPr/>
+        </p:nvCxnSpPr>
+        <p:spPr>
+          <a:xfrm rot="16200000" flipV="1">
+            <a:off x="8663782" y="1861373"/>
+            <a:ext cx="1473235" cy="272250"/>
+          </a:xfrm>
+          <a:prstGeom prst="bentConnector3">
+            <a:avLst/>
+          </a:prstGeom>
+          <a:ln>
+            <a:solidFill>
+              <a:schemeClr val="tx1"/>
+            </a:solidFill>
+            <a:tailEnd type="triangle" w="lg" len="lg"/>
+          </a:ln>
+        </p:spPr>
+        <p:style>
+          <a:lnRef idx="2">
+            <a:schemeClr val="accent1"/>
+          </a:lnRef>
+          <a:fillRef idx="0">
+            <a:schemeClr val="accent1"/>
+          </a:fillRef>
+          <a:effectRef idx="1">
+            <a:schemeClr val="accent1"/>
+          </a:effectRef>
+          <a:fontRef idx="minor">
+            <a:schemeClr val="tx1"/>
+          </a:fontRef>
+        </p:style>
+      </p:cxnSp>
+      <p:cxnSp>
+        <p:nvCxnSpPr>
+          <p:cNvPr id="89" name="Straight Arrow Connector 88">
+            <a:extLst>
+              <a:ext uri="{FF2B5EF4-FFF2-40B4-BE49-F238E27FC236}">
+                <a16:creationId xmlns:a16="http://schemas.microsoft.com/office/drawing/2014/main" id="{057257F3-133D-1AB5-60C0-ED39A0EF12A4}"/>
+              </a:ext>
+            </a:extLst>
+          </p:cNvPr>
+          <p:cNvCxnSpPr>
+            <a:cxnSpLocks/>
+            <a:stCxn id="6" idx="2"/>
+            <a:endCxn id="7" idx="0"/>
+          </p:cNvCxnSpPr>
+          <p:nvPr/>
+        </p:nvCxnSpPr>
+        <p:spPr>
+          <a:xfrm>
+            <a:off x="3044040" y="5050316"/>
+            <a:ext cx="0" cy="415388"/>
+          </a:xfrm>
+          <a:prstGeom prst="straightConnector1">
+            <a:avLst/>
+          </a:prstGeom>
+          <a:ln>
+            <a:solidFill>
+              <a:schemeClr val="tx1"/>
+            </a:solidFill>
+            <a:tailEnd type="arrow" w="lg" len="lg"/>
+          </a:ln>
+        </p:spPr>
+        <p:style>
+          <a:lnRef idx="2">
+            <a:schemeClr val="accent1"/>
+          </a:lnRef>
+          <a:fillRef idx="0">
+            <a:schemeClr val="accent1"/>
+          </a:fillRef>
+          <a:effectRef idx="1">
+            <a:schemeClr val="accent1"/>
+          </a:effectRef>
+          <a:fontRef idx="minor">
+            <a:schemeClr val="tx1"/>
+          </a:fontRef>
+        </p:style>
+      </p:cxnSp>
+      <p:sp>
+        <p:nvSpPr>
+          <p:cNvPr id="94" name="TextBox 93">
+            <a:extLst>
+              <a:ext uri="{FF2B5EF4-FFF2-40B4-BE49-F238E27FC236}">
+                <a16:creationId xmlns:a16="http://schemas.microsoft.com/office/drawing/2014/main" id="{A13240BA-A231-C881-01B7-661188EF33B0}"/>
+              </a:ext>
+            </a:extLst>
+          </p:cNvPr>
+          <p:cNvSpPr txBox="1"/>
+          <p:nvPr/>
+        </p:nvSpPr>
+        <p:spPr>
+          <a:xfrm>
+            <a:off x="3044039" y="5187730"/>
+            <a:ext cx="251992" cy="253916"/>
+          </a:xfrm>
+          <a:prstGeom prst="rect">
+            <a:avLst/>
+          </a:prstGeom>
+          <a:noFill/>
+        </p:spPr>
+        <p:txBody>
+          <a:bodyPr wrap="none" rtlCol="0">
+            <a:spAutoFit/>
+          </a:bodyPr>
+          <a:lstStyle/>
+          <a:p>
+            <a:r>
+              <a:rPr lang="en-US" sz="1050" dirty="0"/>
+              <a:t>*</a:t>
+            </a:r>
+          </a:p>
+        </p:txBody>
+      </p:sp>
+      <p:sp>
+        <p:nvSpPr>
+          <p:cNvPr id="98" name="Speech Bubble: Rectangle with Corners Rounded 97">
+            <a:extLst>
+              <a:ext uri="{FF2B5EF4-FFF2-40B4-BE49-F238E27FC236}">
+                <a16:creationId xmlns:a16="http://schemas.microsoft.com/office/drawing/2014/main" id="{8D18C21D-B749-86EC-C946-0C6448C8BB9D}"/>
+              </a:ext>
+            </a:extLst>
+          </p:cNvPr>
+          <p:cNvSpPr/>
+          <p:nvPr/>
+        </p:nvSpPr>
+        <p:spPr>
+          <a:xfrm>
+            <a:off x="200025" y="629299"/>
+            <a:ext cx="3844480" cy="699787"/>
+          </a:xfrm>
+          <a:prstGeom prst="wedgeRoundRectCallout">
+            <a:avLst>
+              <a:gd name="adj1" fmla="val 22029"/>
+              <a:gd name="adj2" fmla="val 96192"/>
+              <a:gd name="adj3" fmla="val 16667"/>
+            </a:avLst>
+          </a:prstGeom>
+          <a:solidFill>
+            <a:srgbClr val="FFFC8F"/>
+          </a:solidFill>
+          <a:ln w="12700">
+            <a:solidFill>
+              <a:schemeClr val="tx1"/>
+            </a:solidFill>
+          </a:ln>
+        </p:spPr>
+        <p:style>
+          <a:lnRef idx="2">
+            <a:schemeClr val="accent1">
+              <a:shade val="15000"/>
+            </a:schemeClr>
+          </a:lnRef>
+          <a:fillRef idx="1">
+            <a:schemeClr val="accent1"/>
+          </a:fillRef>
+          <a:effectRef idx="0">
+            <a:schemeClr val="accent1"/>
+          </a:effectRef>
+          <a:fontRef idx="minor">
+            <a:schemeClr val="lt1"/>
+          </a:fontRef>
+        </p:style>
+        <p:txBody>
+          <a:bodyPr rtlCol="0" anchor="t"/>
+          <a:lstStyle/>
+          <a:p>
+            <a:r>
+              <a:rPr lang="en-US" sz="1200" dirty="0">
+                <a:solidFill>
+                  <a:schemeClr val="tx1"/>
+                </a:solidFill>
+              </a:rPr>
+              <a:t>Simulator.  After the first </a:t>
+            </a:r>
+            <a:r>
+              <a:rPr lang="en-US" sz="1200" b="1" dirty="0" err="1">
+                <a:solidFill>
+                  <a:schemeClr val="tx1"/>
+                </a:solidFill>
+              </a:rPr>
+              <a:t>ComputeJob</a:t>
+            </a:r>
+            <a:r>
+              <a:rPr lang="en-US" sz="1200" dirty="0">
+                <a:solidFill>
+                  <a:schemeClr val="tx1"/>
+                </a:solidFill>
+              </a:rPr>
+              <a:t>(s) and/or </a:t>
+            </a:r>
+            <a:r>
+              <a:rPr lang="en-US" sz="1200" b="1" dirty="0" err="1">
+                <a:solidFill>
+                  <a:schemeClr val="tx1"/>
+                </a:solidFill>
+              </a:rPr>
+              <a:t>DataBatch</a:t>
+            </a:r>
+            <a:r>
+              <a:rPr lang="en-US" sz="1200" dirty="0">
+                <a:solidFill>
+                  <a:schemeClr val="tx1"/>
+                </a:solidFill>
+              </a:rPr>
+              <a:t>(es) have been added to it, call its </a:t>
+            </a:r>
+            <a:r>
+              <a:rPr lang="en-US" sz="1200" b="1" dirty="0">
+                <a:solidFill>
+                  <a:schemeClr val="tx1"/>
+                </a:solidFill>
+              </a:rPr>
+              <a:t>run()</a:t>
+            </a:r>
+            <a:r>
+              <a:rPr lang="en-US" sz="1200" dirty="0">
+                <a:solidFill>
+                  <a:schemeClr val="tx1"/>
+                </a:solidFill>
+              </a:rPr>
+              <a:t> method to run the simulation in discrete time increments.</a:t>
+            </a:r>
+            <a:endParaRPr lang="en-US" sz="1200" b="1" dirty="0">
+              <a:solidFill>
+                <a:schemeClr val="tx1"/>
+              </a:solidFill>
+            </a:endParaRPr>
+          </a:p>
+        </p:txBody>
+      </p:sp>
+      <p:sp>
+        <p:nvSpPr>
+          <p:cNvPr id="99" name="Speech Bubble: Rectangle with Corners Rounded 98">
+            <a:extLst>
+              <a:ext uri="{FF2B5EF4-FFF2-40B4-BE49-F238E27FC236}">
+                <a16:creationId xmlns:a16="http://schemas.microsoft.com/office/drawing/2014/main" id="{33AA9F11-7472-4060-CF90-50FE0503C3A4}"/>
+              </a:ext>
+            </a:extLst>
+          </p:cNvPr>
+          <p:cNvSpPr/>
+          <p:nvPr/>
+        </p:nvSpPr>
+        <p:spPr>
+          <a:xfrm>
+            <a:off x="9749522" y="1768592"/>
+            <a:ext cx="2260657" cy="658950"/>
+          </a:xfrm>
+          <a:prstGeom prst="wedgeRoundRectCallout">
+            <a:avLst>
+              <a:gd name="adj1" fmla="val -22808"/>
+              <a:gd name="adj2" fmla="val -88174"/>
+              <a:gd name="adj3" fmla="val 16667"/>
+            </a:avLst>
+          </a:prstGeom>
+          <a:solidFill>
+            <a:srgbClr val="FFFC8F"/>
+          </a:solidFill>
+          <a:ln w="12700">
+            <a:solidFill>
+              <a:schemeClr val="tx1"/>
+            </a:solidFill>
+          </a:ln>
+        </p:spPr>
+        <p:style>
+          <a:lnRef idx="2">
+            <a:schemeClr val="accent1">
+              <a:shade val="15000"/>
+            </a:schemeClr>
+          </a:lnRef>
+          <a:fillRef idx="1">
+            <a:schemeClr val="accent1"/>
+          </a:fillRef>
+          <a:effectRef idx="0">
+            <a:schemeClr val="accent1"/>
+          </a:effectRef>
+          <a:fontRef idx="minor">
+            <a:schemeClr val="lt1"/>
+          </a:fontRef>
+        </p:style>
+        <p:txBody>
+          <a:bodyPr rtlCol="0" anchor="t"/>
+          <a:lstStyle/>
+          <a:p>
+            <a:r>
+              <a:rPr lang="en-US" sz="1400" dirty="0">
+                <a:solidFill>
+                  <a:schemeClr val="tx1"/>
+                </a:solidFill>
+              </a:rPr>
+              <a:t>Simulator interface with two event handlers</a:t>
+            </a:r>
+            <a:endParaRPr lang="en-US" sz="1400" b="1" dirty="0">
+              <a:solidFill>
+                <a:schemeClr val="tx1"/>
+              </a:solidFill>
+            </a:endParaRPr>
+          </a:p>
+        </p:txBody>
+      </p:sp>
+      <p:sp>
+        <p:nvSpPr>
+          <p:cNvPr id="100" name="Speech Bubble: Rectangle with Corners Rounded 99">
+            <a:extLst>
+              <a:ext uri="{FF2B5EF4-FFF2-40B4-BE49-F238E27FC236}">
+                <a16:creationId xmlns:a16="http://schemas.microsoft.com/office/drawing/2014/main" id="{814CCD75-571B-81A9-1E3C-6D855CD75BD1}"/>
+              </a:ext>
+            </a:extLst>
+          </p:cNvPr>
+          <p:cNvSpPr/>
+          <p:nvPr/>
+        </p:nvSpPr>
+        <p:spPr>
+          <a:xfrm>
+            <a:off x="8459150" y="4398234"/>
+            <a:ext cx="3247451" cy="2074045"/>
+          </a:xfrm>
+          <a:prstGeom prst="wedgeRoundRectCallout">
+            <a:avLst>
+              <a:gd name="adj1" fmla="val -22068"/>
+              <a:gd name="adj2" fmla="val -69142"/>
+              <a:gd name="adj3" fmla="val 16667"/>
+            </a:avLst>
+          </a:prstGeom>
+          <a:solidFill>
+            <a:srgbClr val="FFFC8F"/>
+          </a:solidFill>
+          <a:ln w="12700">
+            <a:solidFill>
+              <a:schemeClr val="tx1"/>
+            </a:solidFill>
+          </a:ln>
+        </p:spPr>
+        <p:style>
+          <a:lnRef idx="2">
+            <a:schemeClr val="accent1">
+              <a:shade val="15000"/>
+            </a:schemeClr>
+          </a:lnRef>
+          <a:fillRef idx="1">
+            <a:schemeClr val="accent1"/>
+          </a:fillRef>
+          <a:effectRef idx="0">
+            <a:schemeClr val="accent1"/>
+          </a:effectRef>
+          <a:fontRef idx="minor">
+            <a:schemeClr val="lt1"/>
+          </a:fontRef>
+        </p:style>
+        <p:txBody>
+          <a:bodyPr rtlCol="0" anchor="t"/>
+          <a:lstStyle/>
+          <a:p>
+            <a:r>
+              <a:rPr lang="en-US" sz="1200" dirty="0">
+                <a:solidFill>
+                  <a:schemeClr val="tx1"/>
+                </a:solidFill>
+              </a:rPr>
+              <a:t>A concrete system that implements the simulator interface.  Its methods handle events from the simulator announcing the completion of data transfers and compute jobs by orchestrating the creation of additional </a:t>
+            </a:r>
+            <a:r>
+              <a:rPr lang="en-US" sz="1200" b="1" dirty="0" err="1">
+                <a:solidFill>
+                  <a:schemeClr val="tx1"/>
+                </a:solidFill>
+              </a:rPr>
+              <a:t>CommJobs</a:t>
+            </a:r>
+            <a:r>
+              <a:rPr lang="en-US" sz="1200" dirty="0">
+                <a:solidFill>
+                  <a:schemeClr val="tx1"/>
+                </a:solidFill>
+              </a:rPr>
+              <a:t> and </a:t>
+            </a:r>
+            <a:r>
+              <a:rPr lang="en-US" sz="1200" b="1" dirty="0" err="1">
+                <a:solidFill>
+                  <a:schemeClr val="tx1"/>
+                </a:solidFill>
+              </a:rPr>
+              <a:t>DataBatches</a:t>
+            </a:r>
+            <a:r>
+              <a:rPr lang="en-US" sz="1200" dirty="0">
+                <a:solidFill>
+                  <a:schemeClr val="tx1"/>
+                </a:solidFill>
+              </a:rPr>
+              <a:t> and submitting them to the simulator.  Its </a:t>
+            </a:r>
+            <a:r>
+              <a:rPr lang="en-US" sz="1200" b="1" dirty="0">
+                <a:solidFill>
+                  <a:schemeClr val="tx1"/>
+                </a:solidFill>
+              </a:rPr>
+              <a:t>start()</a:t>
+            </a:r>
+            <a:r>
+              <a:rPr lang="en-US" sz="1200" dirty="0">
+                <a:solidFill>
+                  <a:schemeClr val="tx1"/>
+                </a:solidFill>
+              </a:rPr>
+              <a:t> method kicks off the first </a:t>
+            </a:r>
+            <a:r>
+              <a:rPr lang="en-US" sz="1200" b="1" dirty="0" err="1">
+                <a:solidFill>
+                  <a:schemeClr val="tx1"/>
+                </a:solidFill>
+              </a:rPr>
+              <a:t>ComputeJob</a:t>
+            </a:r>
+            <a:r>
+              <a:rPr lang="en-US" sz="1200" dirty="0">
+                <a:solidFill>
+                  <a:schemeClr val="tx1"/>
+                </a:solidFill>
+              </a:rPr>
+              <a:t>(s) and/or </a:t>
+            </a:r>
+            <a:r>
+              <a:rPr lang="en-US" sz="1200" b="1" dirty="0" err="1">
+                <a:solidFill>
+                  <a:schemeClr val="tx1"/>
+                </a:solidFill>
+              </a:rPr>
+              <a:t>DataBatch</a:t>
+            </a:r>
+            <a:r>
+              <a:rPr lang="en-US" sz="1200" dirty="0">
+                <a:solidFill>
+                  <a:schemeClr val="tx1"/>
+                </a:solidFill>
+              </a:rPr>
+              <a:t>(es).</a:t>
+            </a:r>
+            <a:endParaRPr lang="en-US" sz="1200" b="1" dirty="0">
+              <a:solidFill>
+                <a:schemeClr val="tx1"/>
+              </a:solidFill>
+            </a:endParaRPr>
+          </a:p>
+        </p:txBody>
+      </p:sp>
+      <p:sp>
+        <p:nvSpPr>
+          <p:cNvPr id="101" name="Rectangle 100">
+            <a:extLst>
+              <a:ext uri="{FF2B5EF4-FFF2-40B4-BE49-F238E27FC236}">
+                <a16:creationId xmlns:a16="http://schemas.microsoft.com/office/drawing/2014/main" id="{B2CC24BB-BA48-1713-63BF-437ED9FE6979}"/>
+              </a:ext>
+            </a:extLst>
+          </p:cNvPr>
+          <p:cNvSpPr/>
+          <p:nvPr/>
+        </p:nvSpPr>
+        <p:spPr>
+          <a:xfrm>
+            <a:off x="8193195" y="3120546"/>
+            <a:ext cx="2686656" cy="383276"/>
+          </a:xfrm>
+          <a:prstGeom prst="rect">
+            <a:avLst/>
+          </a:prstGeom>
+          <a:noFill/>
+          <a:ln>
+            <a:solidFill>
+              <a:schemeClr val="tx1"/>
+            </a:solidFill>
+          </a:ln>
+        </p:spPr>
+        <p:style>
+          <a:lnRef idx="2">
+            <a:schemeClr val="accent1">
+              <a:shade val="15000"/>
+            </a:schemeClr>
+          </a:lnRef>
+          <a:fillRef idx="1">
+            <a:schemeClr val="accent1"/>
+          </a:fillRef>
+          <a:effectRef idx="0">
+            <a:schemeClr val="accent1"/>
+          </a:effectRef>
+          <a:fontRef idx="minor">
+            <a:schemeClr val="lt1"/>
+          </a:fontRef>
+        </p:style>
+        <p:txBody>
+          <a:bodyPr rtlCol="0" anchor="t"/>
+          <a:lstStyle/>
+          <a:p>
+            <a:endParaRPr lang="en-US" sz="1050" dirty="0">
+              <a:solidFill>
+                <a:schemeClr val="tx1"/>
+              </a:solidFill>
+            </a:endParaRPr>
+          </a:p>
+        </p:txBody>
+      </p:sp>
+      <p:sp>
+        <p:nvSpPr>
+          <p:cNvPr id="102" name="Rectangle 101">
+            <a:extLst>
+              <a:ext uri="{FF2B5EF4-FFF2-40B4-BE49-F238E27FC236}">
+                <a16:creationId xmlns:a16="http://schemas.microsoft.com/office/drawing/2014/main" id="{EB870F73-B9F3-0FA9-68F6-739BD08B3EBD}"/>
+              </a:ext>
+            </a:extLst>
+          </p:cNvPr>
+          <p:cNvSpPr/>
+          <p:nvPr/>
+        </p:nvSpPr>
+        <p:spPr>
+          <a:xfrm>
+            <a:off x="8193195" y="3501494"/>
+            <a:ext cx="2686656" cy="383276"/>
+          </a:xfrm>
+          <a:prstGeom prst="rect">
+            <a:avLst/>
+          </a:prstGeom>
+          <a:noFill/>
+          <a:ln>
+            <a:solidFill>
+              <a:schemeClr val="tx1"/>
+            </a:solidFill>
+          </a:ln>
+        </p:spPr>
+        <p:style>
+          <a:lnRef idx="2">
+            <a:schemeClr val="accent1">
+              <a:shade val="15000"/>
+            </a:schemeClr>
+          </a:lnRef>
+          <a:fillRef idx="1">
+            <a:schemeClr val="accent1"/>
+          </a:fillRef>
+          <a:effectRef idx="0">
+            <a:schemeClr val="accent1"/>
+          </a:effectRef>
+          <a:fontRef idx="minor">
+            <a:schemeClr val="lt1"/>
+          </a:fontRef>
+        </p:style>
+        <p:txBody>
+          <a:bodyPr rtlCol="0" anchor="t"/>
+          <a:lstStyle/>
+          <a:p>
+            <a:r>
+              <a:rPr lang="en-US" sz="1050" dirty="0">
+                <a:solidFill>
+                  <a:schemeClr val="tx1"/>
+                </a:solidFill>
+              </a:rPr>
+              <a:t>+start(simulator : </a:t>
+            </a:r>
+            <a:r>
+              <a:rPr lang="en-US" sz="1050" dirty="0" err="1">
+                <a:solidFill>
+                  <a:schemeClr val="tx1"/>
+                </a:solidFill>
+              </a:rPr>
+              <a:t>CommNetworkSimulator</a:t>
+            </a:r>
+            <a:r>
+              <a:rPr lang="en-US" sz="1050" dirty="0">
+                <a:solidFill>
+                  <a:schemeClr val="tx1"/>
+                </a:solidFill>
+              </a:rPr>
+              <a:t>)</a:t>
+            </a:r>
+          </a:p>
+        </p:txBody>
+      </p:sp>
+      <p:sp>
+        <p:nvSpPr>
+          <p:cNvPr id="107" name="Rectangle 106">
+            <a:extLst>
+              <a:ext uri="{FF2B5EF4-FFF2-40B4-BE49-F238E27FC236}">
+                <a16:creationId xmlns:a16="http://schemas.microsoft.com/office/drawing/2014/main" id="{827C0DA1-378A-3C62-78A8-B6ACC7BC7E1C}"/>
+              </a:ext>
+            </a:extLst>
+          </p:cNvPr>
+          <p:cNvSpPr/>
+          <p:nvPr/>
+        </p:nvSpPr>
+        <p:spPr>
+          <a:xfrm>
+            <a:off x="2684040" y="2130420"/>
+            <a:ext cx="3004492" cy="381535"/>
+          </a:xfrm>
+          <a:prstGeom prst="rect">
+            <a:avLst/>
+          </a:prstGeom>
+          <a:noFill/>
+          <a:ln>
+            <a:solidFill>
+              <a:schemeClr val="tx1"/>
+            </a:solidFill>
+          </a:ln>
+        </p:spPr>
+        <p:style>
+          <a:lnRef idx="2">
+            <a:schemeClr val="accent1">
+              <a:shade val="15000"/>
+            </a:schemeClr>
+          </a:lnRef>
+          <a:fillRef idx="1">
+            <a:schemeClr val="accent1"/>
+          </a:fillRef>
+          <a:effectRef idx="0">
+            <a:schemeClr val="accent1"/>
+          </a:effectRef>
+          <a:fontRef idx="minor">
+            <a:schemeClr val="lt1"/>
+          </a:fontRef>
+        </p:style>
+        <p:txBody>
+          <a:bodyPr rtlCol="0" anchor="t"/>
+          <a:lstStyle/>
+          <a:p>
+            <a:r>
+              <a:rPr lang="en-US" sz="1050" dirty="0">
+                <a:solidFill>
+                  <a:schemeClr val="tx1"/>
+                </a:solidFill>
+              </a:rPr>
+              <a:t>+</a:t>
+            </a:r>
+            <a:r>
+              <a:rPr lang="en-US" sz="1050" dirty="0" err="1">
+                <a:solidFill>
+                  <a:schemeClr val="tx1"/>
+                </a:solidFill>
+              </a:rPr>
+              <a:t>current_time</a:t>
+            </a:r>
+            <a:r>
+              <a:rPr lang="en-US" sz="1050" dirty="0">
+                <a:solidFill>
+                  <a:schemeClr val="tx1"/>
+                </a:solidFill>
+              </a:rPr>
+              <a:t> : float</a:t>
+            </a:r>
+          </a:p>
+        </p:txBody>
+      </p:sp>
+      <p:cxnSp>
+        <p:nvCxnSpPr>
+          <p:cNvPr id="113" name="Straight Arrow Connector 112">
+            <a:extLst>
+              <a:ext uri="{FF2B5EF4-FFF2-40B4-BE49-F238E27FC236}">
+                <a16:creationId xmlns:a16="http://schemas.microsoft.com/office/drawing/2014/main" id="{8F3B683E-A875-E988-936D-CAB48316EF34}"/>
+              </a:ext>
+            </a:extLst>
+          </p:cNvPr>
+          <p:cNvCxnSpPr>
+            <a:cxnSpLocks/>
+          </p:cNvCxnSpPr>
+          <p:nvPr/>
+        </p:nvCxnSpPr>
+        <p:spPr>
+          <a:xfrm flipH="1">
+            <a:off x="4595904" y="487080"/>
+            <a:ext cx="1181100" cy="0"/>
+          </a:xfrm>
+          <a:prstGeom prst="straightConnector1">
+            <a:avLst/>
+          </a:prstGeom>
+          <a:ln>
+            <a:tailEnd type="triangle"/>
+          </a:ln>
+        </p:spPr>
+        <p:style>
+          <a:lnRef idx="2">
+            <a:schemeClr val="accent1"/>
+          </a:lnRef>
+          <a:fillRef idx="0">
+            <a:schemeClr val="accent1"/>
+          </a:fillRef>
+          <a:effectRef idx="1">
+            <a:schemeClr val="accent1"/>
+          </a:effectRef>
+          <a:fontRef idx="minor">
+            <a:schemeClr val="tx1"/>
+          </a:fontRef>
+        </p:style>
+      </p:cxnSp>
+      <p:sp>
+        <p:nvSpPr>
+          <p:cNvPr id="114" name="TextBox 113">
+            <a:extLst>
+              <a:ext uri="{FF2B5EF4-FFF2-40B4-BE49-F238E27FC236}">
+                <a16:creationId xmlns:a16="http://schemas.microsoft.com/office/drawing/2014/main" id="{9660B4F0-8C08-DEE4-7E8B-D75A0CD564D0}"/>
+              </a:ext>
+            </a:extLst>
+          </p:cNvPr>
+          <p:cNvSpPr txBox="1"/>
+          <p:nvPr/>
+        </p:nvSpPr>
+        <p:spPr>
+          <a:xfrm>
+            <a:off x="4234110" y="174962"/>
+            <a:ext cx="1904689" cy="253916"/>
+          </a:xfrm>
+          <a:prstGeom prst="rect">
+            <a:avLst/>
+          </a:prstGeom>
+          <a:noFill/>
+        </p:spPr>
+        <p:txBody>
+          <a:bodyPr wrap="none" rtlCol="0">
+            <a:spAutoFit/>
+          </a:bodyPr>
+          <a:lstStyle/>
+          <a:p>
+            <a:pPr algn="ctr"/>
+            <a:r>
+              <a:rPr lang="en-US" sz="1050" dirty="0"/>
+              <a:t>add(_compute() or </a:t>
+            </a:r>
+            <a:r>
+              <a:rPr lang="en-US" sz="1050" dirty="0" err="1"/>
+              <a:t>add_batch</a:t>
+            </a:r>
+            <a:r>
+              <a:rPr lang="en-US" sz="1050" dirty="0"/>
+              <a:t>()</a:t>
+            </a:r>
+          </a:p>
+        </p:txBody>
+      </p:sp>
+      <p:cxnSp>
+        <p:nvCxnSpPr>
+          <p:cNvPr id="115" name="Straight Arrow Connector 114">
+            <a:extLst>
+              <a:ext uri="{FF2B5EF4-FFF2-40B4-BE49-F238E27FC236}">
+                <a16:creationId xmlns:a16="http://schemas.microsoft.com/office/drawing/2014/main" id="{8233520B-3A17-2AD3-5B51-38650D4AA761}"/>
+              </a:ext>
+            </a:extLst>
+          </p:cNvPr>
+          <p:cNvCxnSpPr>
+            <a:cxnSpLocks/>
+          </p:cNvCxnSpPr>
+          <p:nvPr/>
+        </p:nvCxnSpPr>
+        <p:spPr>
+          <a:xfrm>
+            <a:off x="4595904" y="663265"/>
+            <a:ext cx="1181100" cy="0"/>
+          </a:xfrm>
+          <a:prstGeom prst="straightConnector1">
+            <a:avLst/>
+          </a:prstGeom>
+          <a:ln>
+            <a:tailEnd type="triangle"/>
+          </a:ln>
+        </p:spPr>
+        <p:style>
+          <a:lnRef idx="2">
+            <a:schemeClr val="accent1"/>
+          </a:lnRef>
+          <a:fillRef idx="0">
+            <a:schemeClr val="accent1"/>
+          </a:fillRef>
+          <a:effectRef idx="1">
+            <a:schemeClr val="accent1"/>
+          </a:effectRef>
+          <a:fontRef idx="minor">
+            <a:schemeClr val="tx1"/>
+          </a:fontRef>
+        </p:style>
+      </p:cxnSp>
+      <p:sp>
+        <p:nvSpPr>
+          <p:cNvPr id="116" name="TextBox 115">
+            <a:extLst>
+              <a:ext uri="{FF2B5EF4-FFF2-40B4-BE49-F238E27FC236}">
+                <a16:creationId xmlns:a16="http://schemas.microsoft.com/office/drawing/2014/main" id="{5CC52BE4-66E8-12E4-30FB-70BBFF01CCCD}"/>
+              </a:ext>
+            </a:extLst>
+          </p:cNvPr>
+          <p:cNvSpPr txBox="1"/>
+          <p:nvPr/>
+        </p:nvSpPr>
+        <p:spPr>
+          <a:xfrm>
+            <a:off x="4579557" y="719244"/>
+            <a:ext cx="1213795" cy="253916"/>
+          </a:xfrm>
+          <a:prstGeom prst="rect">
+            <a:avLst/>
+          </a:prstGeom>
+          <a:noFill/>
+        </p:spPr>
+        <p:txBody>
+          <a:bodyPr wrap="none" rtlCol="0">
+            <a:spAutoFit/>
+          </a:bodyPr>
+          <a:lstStyle/>
+          <a:p>
+            <a:pPr algn="ctr"/>
+            <a:r>
+              <a:rPr lang="en-US" sz="1050" dirty="0"/>
+              <a:t>Completion events</a:t>
             </a:r>
           </a:p>
         </p:txBody>

</xml_diff>

<commit_message>
Minor fix to image
</commit_message>
<xml_diff>
--- a/docs/Simulator.pptx
+++ b/docs/Simulator.pptx
@@ -9198,8 +9198,8 @@
           </p:sp>
         </mc:Fallback>
       </mc:AlternateContent>
-      <mc:AlternateContent xmlns:mc="http://schemas.openxmlformats.org/markup-compatibility/2006" xmlns:a14="http://schemas.microsoft.com/office/drawing/2010/main">
-        <mc:Choice Requires="a14">
+      <mc:AlternateContent xmlns:mc="http://schemas.openxmlformats.org/markup-compatibility/2006">
+        <mc:Choice xmlns:a14="http://schemas.microsoft.com/office/drawing/2010/main" Requires="a14">
           <p:sp>
             <p:nvSpPr>
               <p:cNvPr id="13" name="Isosceles Triangle 12">
@@ -9254,57 +9254,24 @@
                       <m:jc m:val="centerGroup"/>
                     </m:oMathParaPr>
                     <m:oMath xmlns:m="http://schemas.openxmlformats.org/officeDocument/2006/math">
-                      <m:sSub>
-                        <m:sSubPr>
-                          <m:ctrlPr>
-                            <a:rPr lang="en-US" i="1" smtClean="0">
-                              <a:solidFill>
-                                <a:schemeClr val="tx1"/>
-                              </a:solidFill>
-                              <a:latin typeface="Cambria Math" panose="02040503050406030204" pitchFamily="18" charset="0"/>
-                            </a:rPr>
-                          </m:ctrlPr>
-                        </m:sSubPr>
-                        <m:e>
-                          <m:r>
-                            <a:rPr lang="en-US" b="0" i="1" smtClean="0">
-                              <a:solidFill>
-                                <a:schemeClr val="tx1"/>
-                              </a:solidFill>
-                              <a:latin typeface="Cambria Math" panose="02040503050406030204" pitchFamily="18" charset="0"/>
-                            </a:rPr>
-                            <m:t>𝐶</m:t>
-                          </m:r>
-                        </m:e>
-                        <m:sub>
-                          <m:r>
-                            <a:rPr lang="en-US" b="0" i="1" smtClean="0">
-                              <a:solidFill>
-                                <a:schemeClr val="tx1"/>
-                              </a:solidFill>
-                              <a:latin typeface="Cambria Math" panose="02040503050406030204" pitchFamily="18" charset="0"/>
-                            </a:rPr>
-                            <m:t>𝑋</m:t>
-                          </m:r>
-                        </m:sub>
-                      </m:sSub>
+                      <m:r>
+                        <a:rPr lang="en-US" i="1" smtClean="0">
+                          <a:solidFill>
+                            <a:schemeClr val="tx1"/>
+                          </a:solidFill>
+                          <a:latin typeface="Cambria Math" panose="02040503050406030204" pitchFamily="18" charset="0"/>
+                        </a:rPr>
+                        <m:t>𝐶</m:t>
+                      </m:r>
                     </m:oMath>
                   </m:oMathPara>
                 </a14:m>
-                <a:endParaRPr lang="en-US" dirty="0">
-                  <a:solidFill>
-                    <a:schemeClr val="tx1"/>
-                  </a:solidFill>
-                </a:endParaRPr>
-              </a:p>
-              <a:p>
-                <a:pPr algn="ctr"/>
                 <a:endParaRPr lang="en-US" dirty="0"/>
               </a:p>
             </p:txBody>
           </p:sp>
         </mc:Choice>
-        <mc:Fallback xmlns="">
+        <mc:Fallback>
           <p:sp>
             <p:nvSpPr>
               <p:cNvPr id="13" name="Isosceles Triangle 12">
@@ -9855,8 +9822,8 @@
           </mc:Fallback>
         </mc:AlternateContent>
       </p:grpSp>
-      <mc:AlternateContent xmlns:mc="http://schemas.openxmlformats.org/markup-compatibility/2006" xmlns:a14="http://schemas.microsoft.com/office/drawing/2010/main">
-        <mc:Choice Requires="a14">
+      <mc:AlternateContent xmlns:mc="http://schemas.openxmlformats.org/markup-compatibility/2006">
+        <mc:Choice xmlns:a14="http://schemas.microsoft.com/office/drawing/2010/main" Requires="a14">
           <p:sp>
             <p:nvSpPr>
               <p:cNvPr id="42" name="Speech Bubble: Rectangle with Corners Rounded 41">
@@ -9920,6 +9887,27 @@
                 </a:r>
                 <a14:m>
                   <m:oMath xmlns:m="http://schemas.openxmlformats.org/officeDocument/2006/math">
+                    <m:r>
+                      <a:rPr lang="en-US" sz="1000" i="1" smtClean="0">
+                        <a:solidFill>
+                          <a:schemeClr val="tx1"/>
+                        </a:solidFill>
+                        <a:latin typeface="Cambria Math" panose="02040503050406030204" pitchFamily="18" charset="0"/>
+                      </a:rPr>
+                      <m:t>𝐶</m:t>
+                    </m:r>
+                  </m:oMath>
+                </a14:m>
+                <a:r>
+                  <a:rPr lang="en-US" sz="1000" dirty="0">
+                    <a:solidFill>
+                      <a:schemeClr val="tx1"/>
+                    </a:solidFill>
+                  </a:rPr>
+                  <a:t> is modeled as a time delay </a:t>
+                </a:r>
+                <a14:m>
+                  <m:oMath xmlns:m="http://schemas.openxmlformats.org/officeDocument/2006/math">
                     <m:sSub>
                       <m:sSubPr>
                         <m:ctrlPr>
@@ -9939,7 +9927,7 @@
                             </a:solidFill>
                             <a:latin typeface="Cambria Math" panose="02040503050406030204" pitchFamily="18" charset="0"/>
                           </a:rPr>
-                          <m:t>𝐶</m:t>
+                          <m:t>𝐷</m:t>
                         </m:r>
                       </m:e>
                       <m:sub>
@@ -9950,7 +9938,7 @@
                             </a:solidFill>
                             <a:latin typeface="Cambria Math" panose="02040503050406030204" pitchFamily="18" charset="0"/>
                           </a:rPr>
-                          <m:t>𝑥</m:t>
+                          <m:t>𝐶</m:t>
                         </m:r>
                       </m:sub>
                     </m:sSub>
@@ -9962,7 +9950,7 @@
                       <a:schemeClr val="tx1"/>
                     </a:solidFill>
                   </a:rPr>
-                  <a:t> is modeled as a time delay.</a:t>
+                  <a:t> .</a:t>
                 </a:r>
               </a:p>
               <a:p>
@@ -9975,7 +9963,7 @@
             </p:txBody>
           </p:sp>
         </mc:Choice>
-        <mc:Fallback xmlns="">
+        <mc:Fallback>
           <p:sp>
             <p:nvSpPr>
               <p:cNvPr id="42" name="Speech Bubble: Rectangle with Corners Rounded 41">

</xml_diff>